<commit_message>
feat: tests, upd presentation and diagram
</commit_message>
<xml_diff>
--- a/docs/presentation/FSA-Rental-Presentation.pptx
+++ b/docs/presentation/FSA-Rental-Presentation.pptx
@@ -11,10 +11,11 @@
     <p:sldId id="259" r:id="rId5"/>
     <p:sldId id="260" r:id="rId6"/>
     <p:sldId id="261" r:id="rId7"/>
-    <p:sldId id="267" r:id="rId8"/>
-    <p:sldId id="263" r:id="rId9"/>
-    <p:sldId id="268" r:id="rId10"/>
-    <p:sldId id="265" r:id="rId11"/>
+    <p:sldId id="269" r:id="rId8"/>
+    <p:sldId id="267" r:id="rId9"/>
+    <p:sldId id="263" r:id="rId10"/>
+    <p:sldId id="268" r:id="rId11"/>
+    <p:sldId id="265" r:id="rId12"/>
   </p:sldIdLst>
   <p:sldSz cx="12192000" cy="6858000"/>
   <p:notesSz cx="6858000" cy="9144000"/>
@@ -3459,6 +3460,555 @@
           <a:lstStyle/>
           <a:p>
             <a:pPr algn="ctr"/>
+            <a:endParaRPr/>
+          </a:p>
+        </p:txBody>
+      </p:sp>
+      <p:sp>
+        <p:nvSpPr>
+          <p:cNvPr id="3" name="TextBox 2"/>
+          <p:cNvSpPr txBox="1"/>
+          <p:nvPr/>
+        </p:nvSpPr>
+        <p:spPr>
+          <a:xfrm>
+            <a:off x="-386499" y="653683"/>
+            <a:ext cx="3686118" cy="169277"/>
+          </a:xfrm>
+          <a:prstGeom prst="rect">
+            <a:avLst/>
+          </a:prstGeom>
+          <a:noFill/>
+        </p:spPr>
+        <p:txBody>
+          <a:bodyPr wrap="square" lIns="0" tIns="0" rIns="0" bIns="0" anchor="t">
+            <a:spAutoFit/>
+          </a:bodyPr>
+          <a:lstStyle/>
+          <a:p>
+            <a:pPr algn="ctr"/>
+            <a:r>
+              <a:rPr sz="1100" b="1" dirty="0">
+                <a:solidFill>
+                  <a:srgbClr val="E11D48"/>
+                </a:solidFill>
+                <a:latin typeface="Calibri"/>
+              </a:rPr>
+              <a:t>08  /  TAKEAWAYS</a:t>
+            </a:r>
+          </a:p>
+        </p:txBody>
+      </p:sp>
+      <p:sp>
+        <p:nvSpPr>
+          <p:cNvPr id="4" name="Rounded Rectangle 3"/>
+          <p:cNvSpPr/>
+          <p:nvPr/>
+        </p:nvSpPr>
+        <p:spPr>
+          <a:xfrm>
+            <a:off x="3169767" y="822960"/>
+            <a:ext cx="5852160" cy="1371600"/>
+          </a:xfrm>
+          <a:prstGeom prst="roundRect">
+            <a:avLst>
+              <a:gd name="adj" fmla="val 5000"/>
+            </a:avLst>
+          </a:prstGeom>
+          <a:noFill/>
+          <a:ln w="28575">
+            <a:solidFill>
+              <a:srgbClr val="E11D48"/>
+            </a:solidFill>
+          </a:ln>
+          <a:effectLst/>
+        </p:spPr>
+        <p:style>
+          <a:lnRef idx="1">
+            <a:schemeClr val="accent1"/>
+          </a:lnRef>
+          <a:fillRef idx="3">
+            <a:schemeClr val="accent1"/>
+          </a:fillRef>
+          <a:effectRef idx="2">
+            <a:schemeClr val="accent1"/>
+          </a:effectRef>
+          <a:fontRef idx="minor">
+            <a:schemeClr val="lt1"/>
+          </a:fontRef>
+        </p:style>
+        <p:txBody>
+          <a:bodyPr rtlCol="0" anchor="ctr"/>
+          <a:lstStyle/>
+          <a:p>
+            <a:pPr algn="ctr"/>
+            <a:endParaRPr/>
+          </a:p>
+        </p:txBody>
+      </p:sp>
+      <p:sp>
+        <p:nvSpPr>
+          <p:cNvPr id="5" name="TextBox 4"/>
+          <p:cNvSpPr txBox="1"/>
+          <p:nvPr/>
+        </p:nvSpPr>
+        <p:spPr>
+          <a:xfrm>
+            <a:off x="3169767" y="822960"/>
+            <a:ext cx="5852160" cy="1371600"/>
+          </a:xfrm>
+          <a:prstGeom prst="rect">
+            <a:avLst/>
+          </a:prstGeom>
+          <a:noFill/>
+        </p:spPr>
+        <p:txBody>
+          <a:bodyPr wrap="square" lIns="0" tIns="0" rIns="0" bIns="0" anchor="ctr">
+            <a:spAutoFit/>
+          </a:bodyPr>
+          <a:lstStyle/>
+          <a:p>
+            <a:pPr algn="ctr"/>
+            <a:r>
+              <a:rPr sz="3600" b="1">
+                <a:solidFill>
+                  <a:srgbClr val="F8F5F2"/>
+                </a:solidFill>
+                <a:latin typeface="Calibri"/>
+              </a:rPr>
+              <a:t>What I've</a:t>
+            </a:r>
+          </a:p>
+          <a:p>
+            <a:pPr algn="ctr"/>
+            <a:r>
+              <a:rPr sz="3600" b="1">
+                <a:solidFill>
+                  <a:srgbClr val="F8F5F2"/>
+                </a:solidFill>
+                <a:latin typeface="Calibri"/>
+              </a:rPr>
+              <a:t>learned</a:t>
+            </a:r>
+          </a:p>
+        </p:txBody>
+      </p:sp>
+      <p:sp>
+        <p:nvSpPr>
+          <p:cNvPr id="6" name="TextBox 5"/>
+          <p:cNvSpPr txBox="1"/>
+          <p:nvPr/>
+        </p:nvSpPr>
+        <p:spPr>
+          <a:xfrm>
+            <a:off x="1371600" y="2423160"/>
+            <a:ext cx="640080" cy="868680"/>
+          </a:xfrm>
+          <a:prstGeom prst="rect">
+            <a:avLst/>
+          </a:prstGeom>
+          <a:noFill/>
+        </p:spPr>
+        <p:txBody>
+          <a:bodyPr wrap="square" lIns="0" tIns="0" rIns="0" bIns="0" anchor="ctr">
+            <a:spAutoFit/>
+          </a:bodyPr>
+          <a:lstStyle/>
+          <a:p>
+            <a:pPr algn="ctr"/>
+            <a:r>
+              <a:rPr sz="3200" b="1">
+                <a:solidFill>
+                  <a:srgbClr val="E11D48"/>
+                </a:solidFill>
+                <a:latin typeface="Calibri"/>
+              </a:rPr>
+              <a:t>1</a:t>
+            </a:r>
+          </a:p>
+        </p:txBody>
+      </p:sp>
+      <p:sp>
+        <p:nvSpPr>
+          <p:cNvPr id="7" name="TextBox 6"/>
+          <p:cNvSpPr txBox="1"/>
+          <p:nvPr/>
+        </p:nvSpPr>
+        <p:spPr>
+          <a:xfrm>
+            <a:off x="2194560" y="2423160"/>
+            <a:ext cx="9052560" cy="868680"/>
+          </a:xfrm>
+          <a:prstGeom prst="rect">
+            <a:avLst/>
+          </a:prstGeom>
+          <a:noFill/>
+        </p:spPr>
+        <p:txBody>
+          <a:bodyPr wrap="square" lIns="0" tIns="0" rIns="0" bIns="0" anchor="ctr">
+            <a:spAutoFit/>
+          </a:bodyPr>
+          <a:lstStyle/>
+          <a:p>
+            <a:pPr algn="l"/>
+            <a:r>
+              <a:rPr sz="1500" b="1">
+                <a:solidFill>
+                  <a:srgbClr val="F8F5F2"/>
+                </a:solidFill>
+                <a:latin typeface="Calibri"/>
+              </a:rPr>
+              <a:t>BUILD A FULL-STACK PRODUCT FROM SCRATCH — BACKEND, FRONTEND AND CLOUD</a:t>
+            </a:r>
+          </a:p>
+        </p:txBody>
+      </p:sp>
+      <p:sp>
+        <p:nvSpPr>
+          <p:cNvPr id="8" name="TextBox 7"/>
+          <p:cNvSpPr txBox="1"/>
+          <p:nvPr/>
+        </p:nvSpPr>
+        <p:spPr>
+          <a:xfrm>
+            <a:off x="1371600" y="3291840"/>
+            <a:ext cx="640080" cy="868680"/>
+          </a:xfrm>
+          <a:prstGeom prst="rect">
+            <a:avLst/>
+          </a:prstGeom>
+          <a:noFill/>
+        </p:spPr>
+        <p:txBody>
+          <a:bodyPr wrap="square" lIns="0" tIns="0" rIns="0" bIns="0" anchor="ctr">
+            <a:spAutoFit/>
+          </a:bodyPr>
+          <a:lstStyle/>
+          <a:p>
+            <a:pPr algn="ctr"/>
+            <a:r>
+              <a:rPr sz="3200" b="1">
+                <a:solidFill>
+                  <a:srgbClr val="E11D48"/>
+                </a:solidFill>
+                <a:latin typeface="Calibri"/>
+              </a:rPr>
+              <a:t>2</a:t>
+            </a:r>
+          </a:p>
+        </p:txBody>
+      </p:sp>
+      <p:sp>
+        <p:nvSpPr>
+          <p:cNvPr id="9" name="TextBox 8"/>
+          <p:cNvSpPr txBox="1"/>
+          <p:nvPr/>
+        </p:nvSpPr>
+        <p:spPr>
+          <a:xfrm>
+            <a:off x="2194560" y="3291840"/>
+            <a:ext cx="9052560" cy="868680"/>
+          </a:xfrm>
+          <a:prstGeom prst="rect">
+            <a:avLst/>
+          </a:prstGeom>
+          <a:noFill/>
+        </p:spPr>
+        <p:txBody>
+          <a:bodyPr wrap="square" lIns="0" tIns="0" rIns="0" bIns="0" anchor="ctr">
+            <a:spAutoFit/>
+          </a:bodyPr>
+          <a:lstStyle/>
+          <a:p>
+            <a:pPr algn="l"/>
+            <a:r>
+              <a:rPr sz="1500" b="1">
+                <a:solidFill>
+                  <a:srgbClr val="F8F5F2"/>
+                </a:solidFill>
+                <a:latin typeface="Calibri"/>
+              </a:rPr>
+              <a:t>WRITE CLEAN, WELL-STRUCTURED CODE THAT IS EASY TO EXTEND AND MAINTAIN</a:t>
+            </a:r>
+          </a:p>
+        </p:txBody>
+      </p:sp>
+      <p:sp>
+        <p:nvSpPr>
+          <p:cNvPr id="10" name="TextBox 9"/>
+          <p:cNvSpPr txBox="1"/>
+          <p:nvPr/>
+        </p:nvSpPr>
+        <p:spPr>
+          <a:xfrm>
+            <a:off x="1371600" y="4160520"/>
+            <a:ext cx="640080" cy="868680"/>
+          </a:xfrm>
+          <a:prstGeom prst="rect">
+            <a:avLst/>
+          </a:prstGeom>
+          <a:noFill/>
+        </p:spPr>
+        <p:txBody>
+          <a:bodyPr wrap="square" lIns="0" tIns="0" rIns="0" bIns="0" anchor="ctr">
+            <a:spAutoFit/>
+          </a:bodyPr>
+          <a:lstStyle/>
+          <a:p>
+            <a:pPr algn="ctr"/>
+            <a:r>
+              <a:rPr sz="3200" b="1">
+                <a:solidFill>
+                  <a:srgbClr val="E11D48"/>
+                </a:solidFill>
+                <a:latin typeface="Calibri"/>
+              </a:rPr>
+              <a:t>3</a:t>
+            </a:r>
+          </a:p>
+        </p:txBody>
+      </p:sp>
+      <p:sp>
+        <p:nvSpPr>
+          <p:cNvPr id="11" name="TextBox 10"/>
+          <p:cNvSpPr txBox="1"/>
+          <p:nvPr/>
+        </p:nvSpPr>
+        <p:spPr>
+          <a:xfrm>
+            <a:off x="2194560" y="4160520"/>
+            <a:ext cx="9052560" cy="868680"/>
+          </a:xfrm>
+          <a:prstGeom prst="rect">
+            <a:avLst/>
+          </a:prstGeom>
+          <a:noFill/>
+        </p:spPr>
+        <p:txBody>
+          <a:bodyPr wrap="square" lIns="0" tIns="0" rIns="0" bIns="0" anchor="ctr">
+            <a:spAutoFit/>
+          </a:bodyPr>
+          <a:lstStyle/>
+          <a:p>
+            <a:pPr algn="l"/>
+            <a:r>
+              <a:rPr sz="1500" b="1">
+                <a:solidFill>
+                  <a:srgbClr val="F8F5F2"/>
+                </a:solidFill>
+                <a:latin typeface="Calibri"/>
+              </a:rPr>
+              <a:t>DESIGN A RESPONSIVE INTERFACE THAT WORKS BEAUTIFULLY ON ANY DEVICE</a:t>
+            </a:r>
+          </a:p>
+        </p:txBody>
+      </p:sp>
+      <p:sp>
+        <p:nvSpPr>
+          <p:cNvPr id="12" name="TextBox 11"/>
+          <p:cNvSpPr txBox="1"/>
+          <p:nvPr/>
+        </p:nvSpPr>
+        <p:spPr>
+          <a:xfrm>
+            <a:off x="1371600" y="5029200"/>
+            <a:ext cx="640080" cy="868680"/>
+          </a:xfrm>
+          <a:prstGeom prst="rect">
+            <a:avLst/>
+          </a:prstGeom>
+          <a:noFill/>
+        </p:spPr>
+        <p:txBody>
+          <a:bodyPr wrap="square" lIns="0" tIns="0" rIns="0" bIns="0" anchor="ctr">
+            <a:spAutoFit/>
+          </a:bodyPr>
+          <a:lstStyle/>
+          <a:p>
+            <a:pPr algn="ctr"/>
+            <a:r>
+              <a:rPr sz="3200" b="1">
+                <a:solidFill>
+                  <a:srgbClr val="E11D48"/>
+                </a:solidFill>
+                <a:latin typeface="Calibri"/>
+              </a:rPr>
+              <a:t>4</a:t>
+            </a:r>
+          </a:p>
+        </p:txBody>
+      </p:sp>
+      <p:sp>
+        <p:nvSpPr>
+          <p:cNvPr id="13" name="TextBox 12"/>
+          <p:cNvSpPr txBox="1"/>
+          <p:nvPr/>
+        </p:nvSpPr>
+        <p:spPr>
+          <a:xfrm>
+            <a:off x="2194560" y="5029200"/>
+            <a:ext cx="9052560" cy="868680"/>
+          </a:xfrm>
+          <a:prstGeom prst="rect">
+            <a:avLst/>
+          </a:prstGeom>
+          <a:noFill/>
+        </p:spPr>
+        <p:txBody>
+          <a:bodyPr wrap="square" lIns="0" tIns="0" rIns="0" bIns="0" anchor="ctr">
+            <a:spAutoFit/>
+          </a:bodyPr>
+          <a:lstStyle/>
+          <a:p>
+            <a:pPr algn="l"/>
+            <a:r>
+              <a:rPr sz="1500" b="1">
+                <a:solidFill>
+                  <a:srgbClr val="F8F5F2"/>
+                </a:solidFill>
+                <a:latin typeface="Calibri"/>
+              </a:rPr>
+              <a:t>DEPLOY AND RUN A REAL APPLICATION IN A PRODUCTION ENVIRONMENT</a:t>
+            </a:r>
+          </a:p>
+        </p:txBody>
+      </p:sp>
+      <p:sp>
+        <p:nvSpPr>
+          <p:cNvPr id="14" name="TextBox 13"/>
+          <p:cNvSpPr txBox="1"/>
+          <p:nvPr/>
+        </p:nvSpPr>
+        <p:spPr>
+          <a:xfrm>
+            <a:off x="1371600" y="5897880"/>
+            <a:ext cx="640080" cy="868680"/>
+          </a:xfrm>
+          <a:prstGeom prst="rect">
+            <a:avLst/>
+          </a:prstGeom>
+          <a:noFill/>
+        </p:spPr>
+        <p:txBody>
+          <a:bodyPr wrap="square" lIns="0" tIns="0" rIns="0" bIns="0" anchor="ctr">
+            <a:spAutoFit/>
+          </a:bodyPr>
+          <a:lstStyle/>
+          <a:p>
+            <a:pPr algn="ctr"/>
+            <a:r>
+              <a:rPr sz="3200" b="1">
+                <a:solidFill>
+                  <a:srgbClr val="E11D48"/>
+                </a:solidFill>
+                <a:latin typeface="Calibri"/>
+              </a:rPr>
+              <a:t>5</a:t>
+            </a:r>
+          </a:p>
+        </p:txBody>
+      </p:sp>
+      <p:sp>
+        <p:nvSpPr>
+          <p:cNvPr id="15" name="TextBox 14"/>
+          <p:cNvSpPr txBox="1"/>
+          <p:nvPr/>
+        </p:nvSpPr>
+        <p:spPr>
+          <a:xfrm>
+            <a:off x="2194560" y="5897880"/>
+            <a:ext cx="9052560" cy="868680"/>
+          </a:xfrm>
+          <a:prstGeom prst="rect">
+            <a:avLst/>
+          </a:prstGeom>
+          <a:noFill/>
+        </p:spPr>
+        <p:txBody>
+          <a:bodyPr wrap="square" lIns="0" tIns="0" rIns="0" bIns="0" anchor="ctr">
+            <a:spAutoFit/>
+          </a:bodyPr>
+          <a:lstStyle/>
+          <a:p>
+            <a:pPr algn="l"/>
+            <a:r>
+              <a:rPr sz="1500" b="1">
+                <a:solidFill>
+                  <a:srgbClr val="F8F5F2"/>
+                </a:solidFill>
+                <a:latin typeface="Calibri"/>
+              </a:rPr>
+              <a:t>SOLVE REAL PROBLEMS AND GROW AS A DEVELOPER WITH EVERY COMMIT</a:t>
+            </a:r>
+          </a:p>
+        </p:txBody>
+      </p:sp>
+    </p:spTree>
+  </p:cSld>
+  <p:clrMapOvr>
+    <a:masterClrMapping/>
+  </p:clrMapOvr>
+</p:sld>
+</file>
+
+<file path=ppt/slides/slide11.xml><?xml version="1.0" encoding="utf-8"?>
+<p:sld xmlns:a="http://schemas.openxmlformats.org/drawingml/2006/main" xmlns:r="http://schemas.openxmlformats.org/officeDocument/2006/relationships" xmlns:p="http://schemas.openxmlformats.org/presentationml/2006/main">
+  <p:cSld>
+    <p:spTree>
+      <p:nvGrpSpPr>
+        <p:cNvPr id="1" name=""/>
+        <p:cNvGrpSpPr/>
+        <p:nvPr/>
+      </p:nvGrpSpPr>
+      <p:grpSpPr>
+        <a:xfrm>
+          <a:off x="0" y="0"/>
+          <a:ext cx="0" cy="0"/>
+          <a:chOff x="0" y="0"/>
+          <a:chExt cx="0" cy="0"/>
+        </a:xfrm>
+      </p:grpSpPr>
+      <p:sp>
+        <p:nvSpPr>
+          <p:cNvPr id="2" name="Rectangle 1"/>
+          <p:cNvSpPr/>
+          <p:nvPr/>
+        </p:nvSpPr>
+        <p:spPr>
+          <a:xfrm>
+            <a:off x="0" y="0"/>
+            <a:ext cx="12191695" cy="6858000"/>
+          </a:xfrm>
+          <a:prstGeom prst="rect">
+            <a:avLst/>
+          </a:prstGeom>
+          <a:solidFill>
+            <a:srgbClr val="0B1220"/>
+          </a:solidFill>
+          <a:ln>
+            <a:noFill/>
+          </a:ln>
+          <a:effectLst/>
+        </p:spPr>
+        <p:style>
+          <a:lnRef idx="1">
+            <a:schemeClr val="accent1"/>
+          </a:lnRef>
+          <a:fillRef idx="3">
+            <a:schemeClr val="accent1"/>
+          </a:fillRef>
+          <a:effectRef idx="2">
+            <a:schemeClr val="accent1"/>
+          </a:effectRef>
+          <a:fontRef idx="minor">
+            <a:schemeClr val="lt1"/>
+          </a:fontRef>
+        </p:style>
+        <p:txBody>
+          <a:bodyPr rtlCol="0" anchor="ctr"/>
+          <a:lstStyle/>
+          <a:p>
+            <a:pPr algn="ctr"/>
             <a:endParaRPr dirty="0"/>
           </a:p>
         </p:txBody>
@@ -7714,8 +8264,8 @@
         </p:nvSpPr>
         <p:spPr>
           <a:xfrm>
-            <a:off x="640080" y="457200"/>
-            <a:ext cx="5486400" cy="320040"/>
+            <a:off x="0" y="411480"/>
+            <a:ext cx="12191695" cy="320040"/>
           </a:xfrm>
           <a:prstGeom prst="rect">
             <a:avLst/>
@@ -7728,7 +8278,7 @@
           </a:bodyPr>
           <a:lstStyle/>
           <a:p>
-            <a:pPr algn="l"/>
+            <a:pPr algn="ctr"/>
             <a:r>
               <a:rPr sz="1100" b="1">
                 <a:solidFill>
@@ -7736,7 +8286,7 @@
                 </a:solidFill>
                 <a:latin typeface="Calibri"/>
               </a:rPr>
-              <a:t>DEVELOPMENT PROCESS</a:t>
+              <a:t>EMAIL VERIFICATION</a:t>
             </a:r>
           </a:p>
         </p:txBody>
@@ -7749,8 +8299,8 @@
         </p:nvSpPr>
         <p:spPr>
           <a:xfrm>
-            <a:off x="640080" y="777240"/>
-            <a:ext cx="10972800" cy="914400"/>
+            <a:off x="0" y="777240"/>
+            <a:ext cx="12191695" cy="822960"/>
           </a:xfrm>
           <a:prstGeom prst="rect">
             <a:avLst/>
@@ -7763,35 +8313,142 @@
           </a:bodyPr>
           <a:lstStyle/>
           <a:p>
-            <a:pPr algn="l"/>
-            <a:r>
-              <a:rPr sz="5200" b="1">
+            <a:pPr algn="ctr"/>
+            <a:r>
+              <a:rPr sz="4800" b="1">
                 <a:solidFill>
                   <a:srgbClr val="F8F5F2"/>
                 </a:solidFill>
                 <a:latin typeface="Calibri"/>
               </a:rPr>
-              <a:t>Development stages</a:t>
-            </a:r>
-          </a:p>
-        </p:txBody>
-      </p:sp>
-      <p:sp>
-        <p:nvSpPr>
-          <p:cNvPr id="5" name="Rectangle 4"/>
+              <a:t>It actually sends.</a:t>
+            </a:r>
+          </a:p>
+        </p:txBody>
+      </p:sp>
+      <p:sp>
+        <p:nvSpPr>
+          <p:cNvPr id="5" name="TextBox 4"/>
+          <p:cNvSpPr txBox="1"/>
+          <p:nvPr/>
+        </p:nvSpPr>
+        <p:spPr>
+          <a:xfrm>
+            <a:off x="0" y="1600200"/>
+            <a:ext cx="12191695" cy="365760"/>
+          </a:xfrm>
+          <a:prstGeom prst="rect">
+            <a:avLst/>
+          </a:prstGeom>
+          <a:noFill/>
+        </p:spPr>
+        <p:txBody>
+          <a:bodyPr wrap="square" lIns="0" tIns="0" rIns="0" bIns="0" anchor="t">
+            <a:spAutoFit/>
+          </a:bodyPr>
+          <a:lstStyle/>
+          <a:p>
+            <a:pPr algn="ctr"/>
+            <a:r>
+              <a:rPr sz="1400" b="0">
+                <a:solidFill>
+                  <a:srgbClr val="A0AEC0"/>
+                </a:solidFill>
+                <a:latin typeface="Calibri"/>
+              </a:rPr>
+              <a:t>6-digit one-time code · expires in 15 minutes · clears after use</a:t>
+            </a:r>
+          </a:p>
+        </p:txBody>
+      </p:sp>
+      <p:sp>
+        <p:nvSpPr>
+          <p:cNvPr id="7" name="TextBox 6"/>
+          <p:cNvSpPr txBox="1"/>
+          <p:nvPr/>
+        </p:nvSpPr>
+        <p:spPr>
+          <a:xfrm>
+            <a:off x="3901287" y="4023360"/>
+            <a:ext cx="4389120" cy="365760"/>
+          </a:xfrm>
+          <a:prstGeom prst="rect">
+            <a:avLst/>
+          </a:prstGeom>
+          <a:noFill/>
+        </p:spPr>
+        <p:txBody>
+          <a:bodyPr wrap="square" lIns="0" tIns="0" rIns="0" bIns="0" anchor="ctr">
+            <a:spAutoFit/>
+          </a:bodyPr>
+          <a:lstStyle/>
+          <a:p>
+            <a:pPr algn="ctr"/>
+            <a:r>
+              <a:rPr sz="4400" b="1">
+                <a:solidFill>
+                  <a:srgbClr val="B8AEA4"/>
+                </a:solidFill>
+                <a:latin typeface="Calibri"/>
+              </a:rPr>
+              <a:t>+</a:t>
+            </a:r>
+          </a:p>
+        </p:txBody>
+      </p:sp>
+      <p:sp>
+        <p:nvSpPr>
+          <p:cNvPr id="8" name="TextBox 7"/>
+          <p:cNvSpPr txBox="1"/>
+          <p:nvPr/>
+        </p:nvSpPr>
+        <p:spPr>
+          <a:xfrm>
+            <a:off x="3901287" y="4480560"/>
+            <a:ext cx="4389120" cy="320040"/>
+          </a:xfrm>
+          <a:prstGeom prst="rect">
+            <a:avLst/>
+          </a:prstGeom>
+          <a:noFill/>
+        </p:spPr>
+        <p:txBody>
+          <a:bodyPr wrap="square" lIns="0" tIns="0" rIns="0" bIns="0" anchor="ctr">
+            <a:spAutoFit/>
+          </a:bodyPr>
+          <a:lstStyle/>
+          <a:p>
+            <a:pPr algn="ctr"/>
+            <a:r>
+              <a:rPr sz="1200" b="1">
+                <a:solidFill>
+                  <a:srgbClr val="7A6F65"/>
+                </a:solidFill>
+                <a:latin typeface="Calibri"/>
+              </a:rPr>
+              <a:t>Email screenshot here</a:t>
+            </a:r>
+          </a:p>
+        </p:txBody>
+      </p:sp>
+      <p:sp>
+        <p:nvSpPr>
+          <p:cNvPr id="9" name="Rounded Rectangle 8"/>
           <p:cNvSpPr/>
           <p:nvPr/>
         </p:nvSpPr>
         <p:spPr>
           <a:xfrm>
-            <a:off x="1731233" y="2788920"/>
-            <a:ext cx="8729228" cy="22860"/>
-          </a:xfrm>
-          <a:prstGeom prst="rect">
-            <a:avLst/>
+            <a:off x="457200" y="2651760"/>
+            <a:ext cx="3291840" cy="1920240"/>
+          </a:xfrm>
+          <a:prstGeom prst="roundRect">
+            <a:avLst>
+              <a:gd name="adj" fmla="val 5000"/>
+            </a:avLst>
           </a:prstGeom>
           <a:solidFill>
-            <a:srgbClr val="263246"/>
+            <a:srgbClr val="1A2332"/>
           </a:solidFill>
           <a:ln>
             <a:noFill/>
@@ -7823,98 +8480,16 @@
       </p:sp>
       <p:sp>
         <p:nvSpPr>
-          <p:cNvPr id="6" name="Oval 5"/>
+          <p:cNvPr id="10" name="Rectangle 9"/>
           <p:cNvSpPr/>
           <p:nvPr/>
         </p:nvSpPr>
         <p:spPr>
           <a:xfrm>
-            <a:off x="1402049" y="1874519"/>
-            <a:ext cx="658368" cy="658368"/>
-          </a:xfrm>
-          <a:prstGeom prst="ellipse">
-            <a:avLst/>
-          </a:prstGeom>
-          <a:solidFill>
-            <a:srgbClr val="1A2332"/>
-          </a:solidFill>
-          <a:ln w="25400">
-            <a:solidFill>
-              <a:srgbClr val="E11D48"/>
-            </a:solidFill>
-          </a:ln>
-          <a:effectLst/>
-        </p:spPr>
-        <p:style>
-          <a:lnRef idx="1">
-            <a:schemeClr val="accent1"/>
-          </a:lnRef>
-          <a:fillRef idx="3">
-            <a:schemeClr val="accent1"/>
-          </a:fillRef>
-          <a:effectRef idx="2">
-            <a:schemeClr val="accent1"/>
-          </a:effectRef>
-          <a:fontRef idx="minor">
-            <a:schemeClr val="lt1"/>
-          </a:fontRef>
-        </p:style>
-        <p:txBody>
-          <a:bodyPr rtlCol="0" anchor="ctr"/>
-          <a:lstStyle/>
-          <a:p>
-            <a:pPr algn="ctr"/>
-            <a:endParaRPr/>
-          </a:p>
-        </p:txBody>
-      </p:sp>
-      <p:sp>
-        <p:nvSpPr>
-          <p:cNvPr id="7" name="TextBox 6"/>
-          <p:cNvSpPr txBox="1"/>
-          <p:nvPr/>
-        </p:nvSpPr>
-        <p:spPr>
-          <a:xfrm>
-            <a:off x="1402049" y="1874519"/>
-            <a:ext cx="658368" cy="658368"/>
-          </a:xfrm>
-          <a:prstGeom prst="rect">
-            <a:avLst/>
-          </a:prstGeom>
-          <a:noFill/>
-        </p:spPr>
-        <p:txBody>
-          <a:bodyPr wrap="square" lIns="0" tIns="0" rIns="0" bIns="0" anchor="ctr">
-            <a:spAutoFit/>
-          </a:bodyPr>
-          <a:lstStyle/>
-          <a:p>
-            <a:pPr algn="ctr"/>
-            <a:r>
-              <a:rPr sz="2000" b="1">
-                <a:solidFill>
-                  <a:srgbClr val="E11D48"/>
-                </a:solidFill>
-                <a:latin typeface="Calibri"/>
-              </a:rPr>
-              <a:t>01</a:t>
-            </a:r>
-          </a:p>
-        </p:txBody>
-      </p:sp>
-      <p:sp>
-        <p:nvSpPr>
-          <p:cNvPr id="8" name="Oval 7"/>
-          <p:cNvSpPr/>
-          <p:nvPr/>
-        </p:nvSpPr>
-        <p:spPr>
-          <a:xfrm>
-            <a:off x="1648937" y="2706624"/>
-            <a:ext cx="164592" cy="164592"/>
-          </a:xfrm>
-          <a:prstGeom prst="ellipse">
+            <a:off x="640080" y="2971800"/>
+            <a:ext cx="274320" cy="36576"/>
+          </a:xfrm>
+          <a:prstGeom prst="rect">
             <a:avLst/>
           </a:prstGeom>
           <a:solidFill>
@@ -7950,20 +8525,116 @@
       </p:sp>
       <p:sp>
         <p:nvSpPr>
-          <p:cNvPr id="9" name="Rectangle 8"/>
+          <p:cNvPr id="11" name="TextBox 10"/>
+          <p:cNvSpPr txBox="1"/>
+          <p:nvPr/>
+        </p:nvSpPr>
+        <p:spPr>
+          <a:xfrm>
+            <a:off x="640080" y="3108960"/>
+            <a:ext cx="2926080" cy="365760"/>
+          </a:xfrm>
+          <a:prstGeom prst="rect">
+            <a:avLst/>
+          </a:prstGeom>
+          <a:noFill/>
+        </p:spPr>
+        <p:txBody>
+          <a:bodyPr wrap="square" lIns="0" tIns="0" rIns="0" bIns="0" anchor="t">
+            <a:spAutoFit/>
+          </a:bodyPr>
+          <a:lstStyle/>
+          <a:p>
+            <a:pPr algn="l"/>
+            <a:r>
+              <a:rPr sz="1400" b="1">
+                <a:solidFill>
+                  <a:srgbClr val="F8F5F2"/>
+                </a:solidFill>
+                <a:latin typeface="Calibri"/>
+              </a:rPr>
+              <a:t>Email notifications</a:t>
+            </a:r>
+          </a:p>
+        </p:txBody>
+      </p:sp>
+      <p:sp>
+        <p:nvSpPr>
+          <p:cNvPr id="12" name="TextBox 11"/>
+          <p:cNvSpPr txBox="1"/>
+          <p:nvPr/>
+        </p:nvSpPr>
+        <p:spPr>
+          <a:xfrm>
+            <a:off x="640080" y="3566160"/>
+            <a:ext cx="2926080" cy="914400"/>
+          </a:xfrm>
+          <a:prstGeom prst="rect">
+            <a:avLst/>
+          </a:prstGeom>
+          <a:noFill/>
+        </p:spPr>
+        <p:txBody>
+          <a:bodyPr wrap="square" lIns="0" tIns="0" rIns="0" bIns="0" anchor="t">
+            <a:spAutoFit/>
+          </a:bodyPr>
+          <a:lstStyle/>
+          <a:p>
+            <a:pPr algn="l"/>
+            <a:r>
+              <a:rPr sz="1200" b="0">
+                <a:solidFill>
+                  <a:srgbClr val="A0AEC0"/>
+                </a:solidFill>
+                <a:latin typeface="Calibri"/>
+              </a:rPr>
+              <a:t>The platform sends emails to keep</a:t>
+            </a:r>
+          </a:p>
+          <a:p>
+            <a:pPr algn="l"/>
+            <a:r>
+              <a:rPr sz="1200" b="0">
+                <a:solidFill>
+                  <a:srgbClr val="A0AEC0"/>
+                </a:solidFill>
+                <a:latin typeface="Calibri"/>
+              </a:rPr>
+              <a:t>users informed about activity</a:t>
+            </a:r>
+          </a:p>
+          <a:p>
+            <a:pPr algn="l"/>
+            <a:r>
+              <a:rPr sz="1200" b="0">
+                <a:solidFill>
+                  <a:srgbClr val="A0AEC0"/>
+                </a:solidFill>
+                <a:latin typeface="Calibri"/>
+              </a:rPr>
+              <a:t>on their account.</a:t>
+            </a:r>
+          </a:p>
+        </p:txBody>
+      </p:sp>
+      <p:sp>
+        <p:nvSpPr>
+          <p:cNvPr id="13" name="Rounded Rectangle 12"/>
           <p:cNvSpPr/>
           <p:nvPr/>
         </p:nvSpPr>
         <p:spPr>
           <a:xfrm>
-            <a:off x="1717517" y="2532887"/>
-            <a:ext cx="27432" cy="256033"/>
-          </a:xfrm>
-          <a:prstGeom prst="rect">
-            <a:avLst/>
+            <a:off x="8442655" y="2651760"/>
+            <a:ext cx="3291840" cy="1920240"/>
+          </a:xfrm>
+          <a:prstGeom prst="roundRect">
+            <a:avLst>
+              <a:gd name="adj" fmla="val 5000"/>
+            </a:avLst>
           </a:prstGeom>
           <a:solidFill>
-            <a:srgbClr val="263246"/>
+            <a:srgbClr val="1A2332"/>
           </a:solidFill>
           <a:ln>
             <a:noFill/>
@@ -7995,204 +8666,16 @@
       </p:sp>
       <p:sp>
         <p:nvSpPr>
-          <p:cNvPr id="10" name="TextBox 9"/>
-          <p:cNvSpPr txBox="1"/>
-          <p:nvPr/>
-        </p:nvSpPr>
-        <p:spPr>
-          <a:xfrm>
-            <a:off x="731520" y="3794760"/>
-            <a:ext cx="1999427" cy="822960"/>
-          </a:xfrm>
-          <a:prstGeom prst="rect">
-            <a:avLst/>
-          </a:prstGeom>
-          <a:noFill/>
-        </p:spPr>
-        <p:txBody>
-          <a:bodyPr wrap="square" lIns="0" tIns="0" rIns="0" bIns="0" anchor="t">
-            <a:spAutoFit/>
-          </a:bodyPr>
-          <a:lstStyle/>
-          <a:p>
-            <a:pPr algn="ctr"/>
-            <a:r>
-              <a:rPr sz="1600" b="1">
-                <a:solidFill>
-                  <a:srgbClr val="F8F5F2"/>
-                </a:solidFill>
-                <a:latin typeface="Calibri"/>
-              </a:rPr>
-              <a:t>Domain</a:t>
-            </a:r>
-          </a:p>
-          <a:p>
-            <a:pPr algn="ctr"/>
-            <a:r>
-              <a:rPr sz="1600" b="1">
-                <a:solidFill>
-                  <a:srgbClr val="F8F5F2"/>
-                </a:solidFill>
-                <a:latin typeface="Calibri"/>
-              </a:rPr>
-              <a:t>Model</a:t>
-            </a:r>
-          </a:p>
-        </p:txBody>
-      </p:sp>
-      <p:sp>
-        <p:nvSpPr>
-          <p:cNvPr id="11" name="TextBox 10"/>
-          <p:cNvSpPr txBox="1"/>
-          <p:nvPr/>
-        </p:nvSpPr>
-        <p:spPr>
-          <a:xfrm>
-            <a:off x="731520" y="4663440"/>
-            <a:ext cx="1999427" cy="1188720"/>
-          </a:xfrm>
-          <a:prstGeom prst="rect">
-            <a:avLst/>
-          </a:prstGeom>
-          <a:noFill/>
-        </p:spPr>
-        <p:txBody>
-          <a:bodyPr wrap="square" lIns="0" tIns="0" rIns="0" bIns="0" anchor="t">
-            <a:spAutoFit/>
-          </a:bodyPr>
-          <a:lstStyle/>
-          <a:p>
-            <a:pPr algn="ctr"/>
-            <a:r>
-              <a:rPr sz="1200" b="0">
-                <a:solidFill>
-                  <a:srgbClr val="A0AEC0"/>
-                </a:solidFill>
-                <a:latin typeface="Calibri"/>
-              </a:rPr>
-              <a:t>Entities, value objects</a:t>
-            </a:r>
-          </a:p>
-          <a:p>
-            <a:pPr algn="ctr"/>
-            <a:r>
-              <a:rPr sz="1200" b="0">
-                <a:solidFill>
-                  <a:srgbClr val="A0AEC0"/>
-                </a:solidFill>
-                <a:latin typeface="Calibri"/>
-              </a:rPr>
-              <a:t>and business rules</a:t>
-            </a:r>
-          </a:p>
-          <a:p>
-            <a:pPr algn="ctr"/>
-            <a:r>
-              <a:rPr sz="1200" b="0">
-                <a:solidFill>
-                  <a:srgbClr val="A0AEC0"/>
-                </a:solidFill>
-                <a:latin typeface="Calibri"/>
-              </a:rPr>
-              <a:t>with DDD</a:t>
-            </a:r>
-          </a:p>
-        </p:txBody>
-      </p:sp>
-      <p:sp>
-        <p:nvSpPr>
-          <p:cNvPr id="12" name="Oval 11"/>
+          <p:cNvPr id="14" name="Rectangle 13"/>
           <p:cNvSpPr/>
           <p:nvPr/>
         </p:nvSpPr>
         <p:spPr>
           <a:xfrm>
-            <a:off x="3584356" y="1874519"/>
-            <a:ext cx="658368" cy="658368"/>
-          </a:xfrm>
-          <a:prstGeom prst="ellipse">
-            <a:avLst/>
-          </a:prstGeom>
-          <a:solidFill>
-            <a:srgbClr val="1A2332"/>
-          </a:solidFill>
-          <a:ln w="25400">
-            <a:solidFill>
-              <a:srgbClr val="E11D48"/>
-            </a:solidFill>
-          </a:ln>
-          <a:effectLst/>
-        </p:spPr>
-        <p:style>
-          <a:lnRef idx="1">
-            <a:schemeClr val="accent1"/>
-          </a:lnRef>
-          <a:fillRef idx="3">
-            <a:schemeClr val="accent1"/>
-          </a:fillRef>
-          <a:effectRef idx="2">
-            <a:schemeClr val="accent1"/>
-          </a:effectRef>
-          <a:fontRef idx="minor">
-            <a:schemeClr val="lt1"/>
-          </a:fontRef>
-        </p:style>
-        <p:txBody>
-          <a:bodyPr rtlCol="0" anchor="ctr"/>
-          <a:lstStyle/>
-          <a:p>
-            <a:pPr algn="ctr"/>
-            <a:endParaRPr/>
-          </a:p>
-        </p:txBody>
-      </p:sp>
-      <p:sp>
-        <p:nvSpPr>
-          <p:cNvPr id="13" name="TextBox 12"/>
-          <p:cNvSpPr txBox="1"/>
-          <p:nvPr/>
-        </p:nvSpPr>
-        <p:spPr>
-          <a:xfrm>
-            <a:off x="3584356" y="1874519"/>
-            <a:ext cx="658368" cy="658368"/>
-          </a:xfrm>
-          <a:prstGeom prst="rect">
-            <a:avLst/>
-          </a:prstGeom>
-          <a:noFill/>
-        </p:spPr>
-        <p:txBody>
-          <a:bodyPr wrap="square" lIns="0" tIns="0" rIns="0" bIns="0" anchor="ctr">
-            <a:spAutoFit/>
-          </a:bodyPr>
-          <a:lstStyle/>
-          <a:p>
-            <a:pPr algn="ctr"/>
-            <a:r>
-              <a:rPr sz="2000" b="1">
-                <a:solidFill>
-                  <a:srgbClr val="E11D48"/>
-                </a:solidFill>
-                <a:latin typeface="Calibri"/>
-              </a:rPr>
-              <a:t>02</a:t>
-            </a:r>
-          </a:p>
-        </p:txBody>
-      </p:sp>
-      <p:sp>
-        <p:nvSpPr>
-          <p:cNvPr id="14" name="Oval 13"/>
-          <p:cNvSpPr/>
-          <p:nvPr/>
-        </p:nvSpPr>
-        <p:spPr>
-          <a:xfrm>
-            <a:off x="3831244" y="2706624"/>
-            <a:ext cx="164592" cy="164592"/>
-          </a:xfrm>
-          <a:prstGeom prst="ellipse">
+            <a:off x="8625535" y="2971800"/>
+            <a:ext cx="274320" cy="36576"/>
+          </a:xfrm>
+          <a:prstGeom prst="rect">
             <a:avLst/>
           </a:prstGeom>
           <a:solidFill>
@@ -8228,59 +8711,14 @@
       </p:sp>
       <p:sp>
         <p:nvSpPr>
-          <p:cNvPr id="15" name="Rectangle 14"/>
-          <p:cNvSpPr/>
-          <p:nvPr/>
-        </p:nvSpPr>
-        <p:spPr>
-          <a:xfrm>
-            <a:off x="3899824" y="2532887"/>
-            <a:ext cx="27432" cy="256033"/>
-          </a:xfrm>
-          <a:prstGeom prst="rect">
-            <a:avLst/>
-          </a:prstGeom>
-          <a:solidFill>
-            <a:srgbClr val="263246"/>
-          </a:solidFill>
-          <a:ln>
-            <a:noFill/>
-          </a:ln>
-          <a:effectLst/>
-        </p:spPr>
-        <p:style>
-          <a:lnRef idx="1">
-            <a:schemeClr val="accent1"/>
-          </a:lnRef>
-          <a:fillRef idx="3">
-            <a:schemeClr val="accent1"/>
-          </a:fillRef>
-          <a:effectRef idx="2">
-            <a:schemeClr val="accent1"/>
-          </a:effectRef>
-          <a:fontRef idx="minor">
-            <a:schemeClr val="lt1"/>
-          </a:fontRef>
-        </p:style>
-        <p:txBody>
-          <a:bodyPr rtlCol="0" anchor="ctr"/>
-          <a:lstStyle/>
-          <a:p>
-            <a:pPr algn="ctr"/>
-            <a:endParaRPr/>
-          </a:p>
-        </p:txBody>
-      </p:sp>
-      <p:sp>
-        <p:nvSpPr>
-          <p:cNvPr id="16" name="TextBox 15"/>
+          <p:cNvPr id="15" name="TextBox 14"/>
           <p:cNvSpPr txBox="1"/>
           <p:nvPr/>
         </p:nvSpPr>
         <p:spPr>
           <a:xfrm>
-            <a:off x="2913827" y="3794760"/>
-            <a:ext cx="1999427" cy="822960"/>
+            <a:off x="8625535" y="3108960"/>
+            <a:ext cx="2926080" cy="365760"/>
           </a:xfrm>
           <a:prstGeom prst="rect">
             <a:avLst/>
@@ -8293,41 +8731,29 @@
           </a:bodyPr>
           <a:lstStyle/>
           <a:p>
-            <a:pPr algn="ctr"/>
-            <a:r>
-              <a:rPr sz="1600" b="1">
+            <a:pPr algn="l"/>
+            <a:r>
+              <a:rPr sz="1400" b="1">
                 <a:solidFill>
                   <a:srgbClr val="F8F5F2"/>
                 </a:solidFill>
                 <a:latin typeface="Calibri"/>
               </a:rPr>
-              <a:t>API</a:t>
-            </a:r>
-          </a:p>
-          <a:p>
-            <a:pPr algn="ctr"/>
-            <a:r>
-              <a:rPr sz="1600" b="1">
-                <a:solidFill>
-                  <a:srgbClr val="F8F5F2"/>
-                </a:solidFill>
-                <a:latin typeface="Calibri"/>
-              </a:rPr>
-              <a:t>Design</a:t>
-            </a:r>
-          </a:p>
-        </p:txBody>
-      </p:sp>
-      <p:sp>
-        <p:nvSpPr>
-          <p:cNvPr id="17" name="TextBox 16"/>
+              <a:t>Sent when</a:t>
+            </a:r>
+          </a:p>
+        </p:txBody>
+      </p:sp>
+      <p:sp>
+        <p:nvSpPr>
+          <p:cNvPr id="16" name="TextBox 15"/>
           <p:cNvSpPr txBox="1"/>
           <p:nvPr/>
         </p:nvSpPr>
         <p:spPr>
           <a:xfrm>
-            <a:off x="2913827" y="4663440"/>
-            <a:ext cx="1999427" cy="1188720"/>
+            <a:off x="8625535" y="3566160"/>
+            <a:ext cx="2926080" cy="914400"/>
           </a:xfrm>
           <a:prstGeom prst="rect">
             <a:avLst/>
@@ -8340,7 +8766,7 @@
           </a:bodyPr>
           <a:lstStyle/>
           <a:p>
-            <a:pPr algn="ctr"/>
+            <a:pPr algn="l"/>
             <a:r>
               <a:rPr sz="1200" b="0">
                 <a:solidFill>
@@ -8348,11 +8774,11 @@
                 </a:solidFill>
                 <a:latin typeface="Calibri"/>
               </a:rPr>
-              <a:t>OpenAPI spec, REST</a:t>
-            </a:r>
-          </a:p>
-          <a:p>
-            <a:pPr algn="ctr"/>
+              <a:t>Email verification, new message,</a:t>
+            </a:r>
+          </a:p>
+          <a:p>
+            <a:pPr algn="l"/>
             <a:r>
               <a:rPr sz="1200" b="0">
                 <a:solidFill>
@@ -8360,11 +8786,11 @@
                 </a:solidFill>
                 <a:latin typeface="Calibri"/>
               </a:rPr>
-              <a:t>endpoints and</a:t>
-            </a:r>
-          </a:p>
-          <a:p>
-            <a:pPr algn="ctr"/>
+              <a:t>viewing request, viewing approved</a:t>
+            </a:r>
+          </a:p>
+          <a:p>
+            <a:pPr algn="l"/>
             <a:r>
               <a:rPr sz="1200" b="0">
                 <a:solidFill>
@@ -8372,833 +8798,41 @@
                 </a:solidFill>
                 <a:latin typeface="Calibri"/>
               </a:rPr>
-              <a:t>MapStruct DTOs</a:t>
-            </a:r>
-          </a:p>
-        </p:txBody>
-      </p:sp>
-      <p:sp>
-        <p:nvSpPr>
-          <p:cNvPr id="18" name="Oval 17"/>
-          <p:cNvSpPr/>
-          <p:nvPr/>
-        </p:nvSpPr>
-        <p:spPr>
-          <a:xfrm>
-            <a:off x="5766663" y="1874519"/>
-            <a:ext cx="658368" cy="658368"/>
-          </a:xfrm>
-          <a:prstGeom prst="ellipse">
-            <a:avLst/>
-          </a:prstGeom>
-          <a:solidFill>
-            <a:srgbClr val="1A2332"/>
-          </a:solidFill>
-          <a:ln w="25400">
-            <a:solidFill>
-              <a:srgbClr val="E11D48"/>
-            </a:solidFill>
-          </a:ln>
-          <a:effectLst/>
-        </p:spPr>
-        <p:style>
-          <a:lnRef idx="1">
-            <a:schemeClr val="accent1"/>
-          </a:lnRef>
-          <a:fillRef idx="3">
-            <a:schemeClr val="accent1"/>
-          </a:fillRef>
-          <a:effectRef idx="2">
-            <a:schemeClr val="accent1"/>
-          </a:effectRef>
-          <a:fontRef idx="minor">
-            <a:schemeClr val="lt1"/>
-          </a:fontRef>
-        </p:style>
-        <p:txBody>
-          <a:bodyPr rtlCol="0" anchor="ctr"/>
-          <a:lstStyle/>
-          <a:p>
-            <a:pPr algn="ctr"/>
-            <a:endParaRPr/>
-          </a:p>
-        </p:txBody>
-      </p:sp>
-      <p:sp>
-        <p:nvSpPr>
-          <p:cNvPr id="19" name="TextBox 18"/>
-          <p:cNvSpPr txBox="1"/>
-          <p:nvPr/>
-        </p:nvSpPr>
-        <p:spPr>
-          <a:xfrm>
-            <a:off x="5766663" y="1874519"/>
-            <a:ext cx="658368" cy="658368"/>
-          </a:xfrm>
-          <a:prstGeom prst="rect">
-            <a:avLst/>
-          </a:prstGeom>
-          <a:noFill/>
-        </p:spPr>
-        <p:txBody>
-          <a:bodyPr wrap="square" lIns="0" tIns="0" rIns="0" bIns="0" anchor="ctr">
-            <a:spAutoFit/>
-          </a:bodyPr>
-          <a:lstStyle/>
-          <a:p>
-            <a:pPr algn="ctr"/>
-            <a:r>
-              <a:rPr sz="2000" b="1">
-                <a:solidFill>
-                  <a:srgbClr val="E11D48"/>
-                </a:solidFill>
-                <a:latin typeface="Calibri"/>
-              </a:rPr>
-              <a:t>03</a:t>
-            </a:r>
-          </a:p>
-        </p:txBody>
-      </p:sp>
-      <p:sp>
-        <p:nvSpPr>
-          <p:cNvPr id="20" name="Oval 19"/>
-          <p:cNvSpPr/>
-          <p:nvPr/>
-        </p:nvSpPr>
-        <p:spPr>
-          <a:xfrm>
-            <a:off x="6013551" y="2706624"/>
-            <a:ext cx="164592" cy="164592"/>
-          </a:xfrm>
-          <a:prstGeom prst="ellipse">
-            <a:avLst/>
-          </a:prstGeom>
-          <a:solidFill>
-            <a:srgbClr val="E11D48"/>
-          </a:solidFill>
-          <a:ln>
-            <a:noFill/>
-          </a:ln>
-          <a:effectLst/>
-        </p:spPr>
-        <p:style>
-          <a:lnRef idx="1">
-            <a:schemeClr val="accent1"/>
-          </a:lnRef>
-          <a:fillRef idx="3">
-            <a:schemeClr val="accent1"/>
-          </a:fillRef>
-          <a:effectRef idx="2">
-            <a:schemeClr val="accent1"/>
-          </a:effectRef>
-          <a:fontRef idx="minor">
-            <a:schemeClr val="lt1"/>
-          </a:fontRef>
-        </p:style>
-        <p:txBody>
-          <a:bodyPr rtlCol="0" anchor="ctr"/>
-          <a:lstStyle/>
-          <a:p>
-            <a:pPr algn="ctr"/>
-            <a:endParaRPr/>
-          </a:p>
-        </p:txBody>
-      </p:sp>
-      <p:sp>
-        <p:nvSpPr>
-          <p:cNvPr id="21" name="Rectangle 20"/>
-          <p:cNvSpPr/>
-          <p:nvPr/>
-        </p:nvSpPr>
-        <p:spPr>
-          <a:xfrm>
-            <a:off x="6082131" y="2532887"/>
-            <a:ext cx="27432" cy="256033"/>
-          </a:xfrm>
-          <a:prstGeom prst="rect">
-            <a:avLst/>
-          </a:prstGeom>
-          <a:solidFill>
-            <a:srgbClr val="263246"/>
-          </a:solidFill>
-          <a:ln>
-            <a:noFill/>
-          </a:ln>
-          <a:effectLst/>
-        </p:spPr>
-        <p:style>
-          <a:lnRef idx="1">
-            <a:schemeClr val="accent1"/>
-          </a:lnRef>
-          <a:fillRef idx="3">
-            <a:schemeClr val="accent1"/>
-          </a:fillRef>
-          <a:effectRef idx="2">
-            <a:schemeClr val="accent1"/>
-          </a:effectRef>
-          <a:fontRef idx="minor">
-            <a:schemeClr val="lt1"/>
-          </a:fontRef>
-        </p:style>
-        <p:txBody>
-          <a:bodyPr rtlCol="0" anchor="ctr"/>
-          <a:lstStyle/>
-          <a:p>
-            <a:pPr algn="ctr"/>
-            <a:endParaRPr/>
-          </a:p>
-        </p:txBody>
-      </p:sp>
-      <p:sp>
-        <p:nvSpPr>
-          <p:cNvPr id="22" name="TextBox 21"/>
-          <p:cNvSpPr txBox="1"/>
-          <p:nvPr/>
-        </p:nvSpPr>
-        <p:spPr>
-          <a:xfrm>
-            <a:off x="5096134" y="3794760"/>
-            <a:ext cx="1999427" cy="822960"/>
-          </a:xfrm>
-          <a:prstGeom prst="rect">
-            <a:avLst/>
-          </a:prstGeom>
-          <a:noFill/>
-        </p:spPr>
-        <p:txBody>
-          <a:bodyPr wrap="square" lIns="0" tIns="0" rIns="0" bIns="0" anchor="t">
-            <a:spAutoFit/>
-          </a:bodyPr>
-          <a:lstStyle/>
-          <a:p>
-            <a:pPr algn="ctr"/>
-            <a:r>
-              <a:rPr sz="1600" b="1">
-                <a:solidFill>
-                  <a:srgbClr val="F8F5F2"/>
-                </a:solidFill>
-                <a:latin typeface="Calibri"/>
-              </a:rPr>
-              <a:t>Back-end</a:t>
-            </a:r>
-          </a:p>
-        </p:txBody>
-      </p:sp>
-      <p:sp>
-        <p:nvSpPr>
-          <p:cNvPr id="23" name="TextBox 22"/>
-          <p:cNvSpPr txBox="1"/>
-          <p:nvPr/>
-        </p:nvSpPr>
-        <p:spPr>
-          <a:xfrm>
-            <a:off x="5096134" y="4663440"/>
-            <a:ext cx="1999427" cy="1188720"/>
-          </a:xfrm>
-          <a:prstGeom prst="rect">
-            <a:avLst/>
-          </a:prstGeom>
-          <a:noFill/>
-        </p:spPr>
-        <p:txBody>
-          <a:bodyPr wrap="square" lIns="0" tIns="0" rIns="0" bIns="0" anchor="t">
-            <a:spAutoFit/>
-          </a:bodyPr>
-          <a:lstStyle/>
-          <a:p>
-            <a:pPr algn="ctr"/>
-            <a:r>
-              <a:rPr sz="1200" b="0">
-                <a:solidFill>
-                  <a:srgbClr val="A0AEC0"/>
-                </a:solidFill>
-                <a:latin typeface="Calibri"/>
-              </a:rPr>
-              <a:t>Spring Boot 4, JPA,</a:t>
-            </a:r>
-          </a:p>
-          <a:p>
-            <a:pPr algn="ctr"/>
-            <a:r>
-              <a:rPr sz="1200" b="0">
-                <a:solidFill>
-                  <a:srgbClr val="A0AEC0"/>
-                </a:solidFill>
-                <a:latin typeface="Calibri"/>
-              </a:rPr>
-              <a:t>PostgreSQL, Liquibase</a:t>
-            </a:r>
-          </a:p>
-          <a:p>
-            <a:pPr algn="ctr"/>
-            <a:r>
-              <a:rPr sz="1200" b="0">
-                <a:solidFill>
-                  <a:srgbClr val="A0AEC0"/>
-                </a:solidFill>
-                <a:latin typeface="Calibri"/>
-              </a:rPr>
-              <a:t>and Keycloak auth</a:t>
-            </a:r>
-          </a:p>
-        </p:txBody>
-      </p:sp>
-      <p:sp>
-        <p:nvSpPr>
-          <p:cNvPr id="24" name="Oval 23"/>
-          <p:cNvSpPr/>
-          <p:nvPr/>
-        </p:nvSpPr>
-        <p:spPr>
-          <a:xfrm>
-            <a:off x="7948970" y="1874519"/>
-            <a:ext cx="658368" cy="658368"/>
-          </a:xfrm>
-          <a:prstGeom prst="ellipse">
-            <a:avLst/>
-          </a:prstGeom>
-          <a:solidFill>
-            <a:srgbClr val="1A2332"/>
-          </a:solidFill>
-          <a:ln w="25400">
-            <a:solidFill>
-              <a:srgbClr val="E11D48"/>
-            </a:solidFill>
-          </a:ln>
-          <a:effectLst/>
-        </p:spPr>
-        <p:style>
-          <a:lnRef idx="1">
-            <a:schemeClr val="accent1"/>
-          </a:lnRef>
-          <a:fillRef idx="3">
-            <a:schemeClr val="accent1"/>
-          </a:fillRef>
-          <a:effectRef idx="2">
-            <a:schemeClr val="accent1"/>
-          </a:effectRef>
-          <a:fontRef idx="minor">
-            <a:schemeClr val="lt1"/>
-          </a:fontRef>
-        </p:style>
-        <p:txBody>
-          <a:bodyPr rtlCol="0" anchor="ctr"/>
-          <a:lstStyle/>
-          <a:p>
-            <a:pPr algn="ctr"/>
-            <a:endParaRPr/>
-          </a:p>
-        </p:txBody>
-      </p:sp>
-      <p:sp>
-        <p:nvSpPr>
-          <p:cNvPr id="25" name="TextBox 24"/>
-          <p:cNvSpPr txBox="1"/>
-          <p:nvPr/>
-        </p:nvSpPr>
-        <p:spPr>
-          <a:xfrm>
-            <a:off x="7948970" y="1874519"/>
-            <a:ext cx="658368" cy="658368"/>
-          </a:xfrm>
-          <a:prstGeom prst="rect">
-            <a:avLst/>
-          </a:prstGeom>
-          <a:noFill/>
-        </p:spPr>
-        <p:txBody>
-          <a:bodyPr wrap="square" lIns="0" tIns="0" rIns="0" bIns="0" anchor="ctr">
-            <a:spAutoFit/>
-          </a:bodyPr>
-          <a:lstStyle/>
-          <a:p>
-            <a:pPr algn="ctr"/>
-            <a:r>
-              <a:rPr sz="2000" b="1">
-                <a:solidFill>
-                  <a:srgbClr val="E11D48"/>
-                </a:solidFill>
-                <a:latin typeface="Calibri"/>
-              </a:rPr>
-              <a:t>04</a:t>
-            </a:r>
-          </a:p>
-        </p:txBody>
-      </p:sp>
-      <p:sp>
-        <p:nvSpPr>
-          <p:cNvPr id="26" name="Oval 25"/>
-          <p:cNvSpPr/>
-          <p:nvPr/>
-        </p:nvSpPr>
-        <p:spPr>
-          <a:xfrm>
-            <a:off x="8195858" y="2706624"/>
-            <a:ext cx="164592" cy="164592"/>
-          </a:xfrm>
-          <a:prstGeom prst="ellipse">
-            <a:avLst/>
-          </a:prstGeom>
-          <a:solidFill>
-            <a:srgbClr val="E11D48"/>
-          </a:solidFill>
-          <a:ln>
-            <a:noFill/>
-          </a:ln>
-          <a:effectLst/>
-        </p:spPr>
-        <p:style>
-          <a:lnRef idx="1">
-            <a:schemeClr val="accent1"/>
-          </a:lnRef>
-          <a:fillRef idx="3">
-            <a:schemeClr val="accent1"/>
-          </a:fillRef>
-          <a:effectRef idx="2">
-            <a:schemeClr val="accent1"/>
-          </a:effectRef>
-          <a:fontRef idx="minor">
-            <a:schemeClr val="lt1"/>
-          </a:fontRef>
-        </p:style>
-        <p:txBody>
-          <a:bodyPr rtlCol="0" anchor="ctr"/>
-          <a:lstStyle/>
-          <a:p>
-            <a:pPr algn="ctr"/>
-            <a:endParaRPr/>
-          </a:p>
-        </p:txBody>
-      </p:sp>
-      <p:sp>
-        <p:nvSpPr>
-          <p:cNvPr id="27" name="Rectangle 26"/>
-          <p:cNvSpPr/>
-          <p:nvPr/>
-        </p:nvSpPr>
-        <p:spPr>
-          <a:xfrm>
-            <a:off x="8264438" y="2532887"/>
-            <a:ext cx="27432" cy="256033"/>
-          </a:xfrm>
-          <a:prstGeom prst="rect">
-            <a:avLst/>
-          </a:prstGeom>
-          <a:solidFill>
-            <a:srgbClr val="263246"/>
-          </a:solidFill>
-          <a:ln>
-            <a:noFill/>
-          </a:ln>
-          <a:effectLst/>
-        </p:spPr>
-        <p:style>
-          <a:lnRef idx="1">
-            <a:schemeClr val="accent1"/>
-          </a:lnRef>
-          <a:fillRef idx="3">
-            <a:schemeClr val="accent1"/>
-          </a:fillRef>
-          <a:effectRef idx="2">
-            <a:schemeClr val="accent1"/>
-          </a:effectRef>
-          <a:fontRef idx="minor">
-            <a:schemeClr val="lt1"/>
-          </a:fontRef>
-        </p:style>
-        <p:txBody>
-          <a:bodyPr rtlCol="0" anchor="ctr"/>
-          <a:lstStyle/>
-          <a:p>
-            <a:pPr algn="ctr"/>
-            <a:endParaRPr/>
-          </a:p>
-        </p:txBody>
-      </p:sp>
-      <p:sp>
-        <p:nvSpPr>
-          <p:cNvPr id="28" name="TextBox 27"/>
-          <p:cNvSpPr txBox="1"/>
-          <p:nvPr/>
-        </p:nvSpPr>
-        <p:spPr>
-          <a:xfrm>
-            <a:off x="7278441" y="3794760"/>
-            <a:ext cx="1999427" cy="822960"/>
-          </a:xfrm>
-          <a:prstGeom prst="rect">
-            <a:avLst/>
-          </a:prstGeom>
-          <a:noFill/>
-        </p:spPr>
-        <p:txBody>
-          <a:bodyPr wrap="square" lIns="0" tIns="0" rIns="0" bIns="0" anchor="t">
-            <a:spAutoFit/>
-          </a:bodyPr>
-          <a:lstStyle/>
-          <a:p>
-            <a:pPr algn="ctr"/>
-            <a:r>
-              <a:rPr sz="1600" b="1">
-                <a:solidFill>
-                  <a:srgbClr val="F8F5F2"/>
-                </a:solidFill>
-                <a:latin typeface="Calibri"/>
-              </a:rPr>
-              <a:t>Front-end</a:t>
-            </a:r>
-          </a:p>
-        </p:txBody>
-      </p:sp>
-      <p:sp>
-        <p:nvSpPr>
-          <p:cNvPr id="29" name="TextBox 28"/>
-          <p:cNvSpPr txBox="1"/>
-          <p:nvPr/>
-        </p:nvSpPr>
-        <p:spPr>
-          <a:xfrm>
-            <a:off x="7278441" y="4663440"/>
-            <a:ext cx="1999427" cy="553998"/>
-          </a:xfrm>
-          <a:prstGeom prst="rect">
-            <a:avLst/>
-          </a:prstGeom>
-          <a:noFill/>
-        </p:spPr>
-        <p:txBody>
-          <a:bodyPr wrap="square" lIns="0" tIns="0" rIns="0" bIns="0" anchor="t">
-            <a:spAutoFit/>
-          </a:bodyPr>
-          <a:lstStyle/>
-          <a:p>
-            <a:pPr algn="ctr"/>
-            <a:r>
-              <a:rPr sz="1200" b="0" dirty="0">
-                <a:solidFill>
-                  <a:srgbClr val="A0AEC0"/>
-                </a:solidFill>
-                <a:latin typeface="Calibri"/>
-              </a:rPr>
-              <a:t>Angular,</a:t>
-            </a:r>
-            <a:r>
-              <a:rPr lang="en-US" sz="1200" b="0" dirty="0">
-                <a:solidFill>
-                  <a:srgbClr val="A0AEC0"/>
-                </a:solidFill>
-                <a:latin typeface="Calibri"/>
-              </a:rPr>
-              <a:t> TS,</a:t>
-            </a:r>
-            <a:r>
-              <a:rPr lang="ru-RU" sz="1200" b="0" dirty="0">
-                <a:solidFill>
-                  <a:srgbClr val="A0AEC0"/>
-                </a:solidFill>
-                <a:latin typeface="Calibri"/>
-              </a:rPr>
-              <a:t> </a:t>
-            </a:r>
-            <a:endParaRPr sz="1200" b="0" dirty="0">
-              <a:solidFill>
-                <a:srgbClr val="A0AEC0"/>
-              </a:solidFill>
-              <a:latin typeface="Calibri"/>
-            </a:endParaRPr>
-          </a:p>
-          <a:p>
-            <a:pPr algn="ctr"/>
-            <a:r>
-              <a:rPr sz="1200" b="0" dirty="0">
-                <a:solidFill>
-                  <a:srgbClr val="A0AEC0"/>
-                </a:solidFill>
-                <a:latin typeface="Calibri"/>
-              </a:rPr>
-              <a:t>Reactive Forms</a:t>
-            </a:r>
-          </a:p>
-          <a:p>
-            <a:pPr algn="ctr"/>
-            <a:r>
-              <a:rPr sz="1200" b="0" dirty="0">
-                <a:solidFill>
-                  <a:srgbClr val="A0AEC0"/>
-                </a:solidFill>
-                <a:latin typeface="Calibri"/>
-              </a:rPr>
-              <a:t>and SCSS</a:t>
-            </a:r>
-          </a:p>
-        </p:txBody>
-      </p:sp>
-      <p:sp>
-        <p:nvSpPr>
-          <p:cNvPr id="30" name="Oval 29"/>
-          <p:cNvSpPr/>
-          <p:nvPr/>
-        </p:nvSpPr>
-        <p:spPr>
-          <a:xfrm>
-            <a:off x="10131277" y="1874519"/>
-            <a:ext cx="658368" cy="658368"/>
-          </a:xfrm>
-          <a:prstGeom prst="ellipse">
-            <a:avLst/>
-          </a:prstGeom>
-          <a:solidFill>
-            <a:srgbClr val="1A2332"/>
-          </a:solidFill>
-          <a:ln w="25400">
-            <a:solidFill>
-              <a:srgbClr val="E11D48"/>
-            </a:solidFill>
-          </a:ln>
-          <a:effectLst/>
-        </p:spPr>
-        <p:style>
-          <a:lnRef idx="1">
-            <a:schemeClr val="accent1"/>
-          </a:lnRef>
-          <a:fillRef idx="3">
-            <a:schemeClr val="accent1"/>
-          </a:fillRef>
-          <a:effectRef idx="2">
-            <a:schemeClr val="accent1"/>
-          </a:effectRef>
-          <a:fontRef idx="minor">
-            <a:schemeClr val="lt1"/>
-          </a:fontRef>
-        </p:style>
-        <p:txBody>
-          <a:bodyPr rtlCol="0" anchor="ctr"/>
-          <a:lstStyle/>
-          <a:p>
-            <a:pPr algn="ctr"/>
-            <a:endParaRPr dirty="0"/>
-          </a:p>
-        </p:txBody>
-      </p:sp>
-      <p:sp>
-        <p:nvSpPr>
-          <p:cNvPr id="31" name="TextBox 30"/>
-          <p:cNvSpPr txBox="1"/>
-          <p:nvPr/>
-        </p:nvSpPr>
-        <p:spPr>
-          <a:xfrm>
-            <a:off x="10131277" y="1874519"/>
-            <a:ext cx="658368" cy="658368"/>
-          </a:xfrm>
-          <a:prstGeom prst="rect">
-            <a:avLst/>
-          </a:prstGeom>
-          <a:noFill/>
-        </p:spPr>
-        <p:txBody>
-          <a:bodyPr wrap="square" lIns="0" tIns="0" rIns="0" bIns="0" anchor="ctr">
-            <a:spAutoFit/>
-          </a:bodyPr>
-          <a:lstStyle/>
-          <a:p>
-            <a:pPr algn="ctr"/>
-            <a:r>
-              <a:rPr sz="2000" b="1" dirty="0">
-                <a:solidFill>
-                  <a:srgbClr val="E11D48"/>
-                </a:solidFill>
-                <a:latin typeface="Calibri"/>
-              </a:rPr>
-              <a:t>05</a:t>
-            </a:r>
-          </a:p>
-        </p:txBody>
-      </p:sp>
-      <p:sp>
-        <p:nvSpPr>
-          <p:cNvPr id="32" name="Oval 31"/>
-          <p:cNvSpPr/>
-          <p:nvPr/>
-        </p:nvSpPr>
-        <p:spPr>
-          <a:xfrm>
-            <a:off x="10378165" y="2706624"/>
-            <a:ext cx="164592" cy="164592"/>
-          </a:xfrm>
-          <a:prstGeom prst="ellipse">
-            <a:avLst/>
-          </a:prstGeom>
-          <a:solidFill>
-            <a:srgbClr val="E11D48"/>
-          </a:solidFill>
-          <a:ln>
-            <a:noFill/>
-          </a:ln>
-          <a:effectLst/>
-        </p:spPr>
-        <p:style>
-          <a:lnRef idx="1">
-            <a:schemeClr val="accent1"/>
-          </a:lnRef>
-          <a:fillRef idx="3">
-            <a:schemeClr val="accent1"/>
-          </a:fillRef>
-          <a:effectRef idx="2">
-            <a:schemeClr val="accent1"/>
-          </a:effectRef>
-          <a:fontRef idx="minor">
-            <a:schemeClr val="lt1"/>
-          </a:fontRef>
-        </p:style>
-        <p:txBody>
-          <a:bodyPr rtlCol="0" anchor="ctr"/>
-          <a:lstStyle/>
-          <a:p>
-            <a:pPr algn="ctr"/>
-            <a:endParaRPr dirty="0"/>
-          </a:p>
-        </p:txBody>
-      </p:sp>
-      <p:sp>
-        <p:nvSpPr>
-          <p:cNvPr id="33" name="Rectangle 32"/>
-          <p:cNvSpPr/>
-          <p:nvPr/>
-        </p:nvSpPr>
-        <p:spPr>
-          <a:xfrm>
-            <a:off x="10446745" y="2532887"/>
-            <a:ext cx="27432" cy="256033"/>
-          </a:xfrm>
-          <a:prstGeom prst="rect">
-            <a:avLst/>
-          </a:prstGeom>
-          <a:solidFill>
-            <a:srgbClr val="263246"/>
-          </a:solidFill>
-          <a:ln>
-            <a:noFill/>
-          </a:ln>
-          <a:effectLst/>
-        </p:spPr>
-        <p:style>
-          <a:lnRef idx="1">
-            <a:schemeClr val="accent1"/>
-          </a:lnRef>
-          <a:fillRef idx="3">
-            <a:schemeClr val="accent1"/>
-          </a:fillRef>
-          <a:effectRef idx="2">
-            <a:schemeClr val="accent1"/>
-          </a:effectRef>
-          <a:fontRef idx="minor">
-            <a:schemeClr val="lt1"/>
-          </a:fontRef>
-        </p:style>
-        <p:txBody>
-          <a:bodyPr rtlCol="0" anchor="ctr"/>
-          <a:lstStyle/>
-          <a:p>
-            <a:pPr algn="ctr"/>
-            <a:endParaRPr dirty="0"/>
-          </a:p>
-        </p:txBody>
-      </p:sp>
-      <p:sp>
-        <p:nvSpPr>
-          <p:cNvPr id="34" name="TextBox 33"/>
-          <p:cNvSpPr txBox="1"/>
-          <p:nvPr/>
-        </p:nvSpPr>
-        <p:spPr>
-          <a:xfrm>
-            <a:off x="9460748" y="3794760"/>
-            <a:ext cx="1999427" cy="822960"/>
-          </a:xfrm>
-          <a:prstGeom prst="rect">
-            <a:avLst/>
-          </a:prstGeom>
-          <a:noFill/>
-        </p:spPr>
-        <p:txBody>
-          <a:bodyPr wrap="square" lIns="0" tIns="0" rIns="0" bIns="0" anchor="t">
-            <a:spAutoFit/>
-          </a:bodyPr>
-          <a:lstStyle/>
-          <a:p>
-            <a:pPr algn="ctr"/>
-            <a:r>
-              <a:rPr sz="1600" b="1" dirty="0">
-                <a:solidFill>
-                  <a:srgbClr val="F8F5F2"/>
-                </a:solidFill>
-                <a:latin typeface="Calibri"/>
-              </a:rPr>
-              <a:t>Deploy</a:t>
-            </a:r>
-          </a:p>
-        </p:txBody>
-      </p:sp>
-      <p:sp>
-        <p:nvSpPr>
-          <p:cNvPr id="35" name="TextBox 34"/>
-          <p:cNvSpPr txBox="1"/>
-          <p:nvPr/>
-        </p:nvSpPr>
-        <p:spPr>
-          <a:xfrm>
-            <a:off x="9460748" y="4663440"/>
-            <a:ext cx="1999427" cy="1188720"/>
-          </a:xfrm>
-          <a:prstGeom prst="rect">
-            <a:avLst/>
-          </a:prstGeom>
-          <a:noFill/>
-        </p:spPr>
-        <p:txBody>
-          <a:bodyPr wrap="square" lIns="0" tIns="0" rIns="0" bIns="0" anchor="t">
-            <a:spAutoFit/>
-          </a:bodyPr>
-          <a:lstStyle/>
-          <a:p>
-            <a:pPr algn="ctr"/>
-            <a:r>
-              <a:rPr sz="1200" b="0" dirty="0">
-                <a:solidFill>
-                  <a:srgbClr val="A0AEC0"/>
-                </a:solidFill>
-                <a:latin typeface="Calibri"/>
-              </a:rPr>
-              <a:t>Docker, GitLab CI/CD,</a:t>
-            </a:r>
-          </a:p>
-          <a:p>
-            <a:pPr algn="ctr"/>
-            <a:r>
-              <a:rPr sz="1200" b="0" dirty="0">
-                <a:solidFill>
-                  <a:srgbClr val="A0AEC0"/>
-                </a:solidFill>
-                <a:latin typeface="Calibri"/>
-              </a:rPr>
-              <a:t>Azure ACR and</a:t>
-            </a:r>
-          </a:p>
-          <a:p>
-            <a:pPr algn="ctr"/>
-            <a:r>
-              <a:rPr sz="1200" b="0" dirty="0">
-                <a:solidFill>
-                  <a:srgbClr val="A0AEC0"/>
-                </a:solidFill>
-                <a:latin typeface="Calibri"/>
-              </a:rPr>
-              <a:t>Kubernetes rollout</a:t>
-            </a:r>
-          </a:p>
-        </p:txBody>
-      </p:sp>
+              <a:t>or rejected, viewing cancelled.</a:t>
+            </a:r>
+          </a:p>
+        </p:txBody>
+      </p:sp>
+      <p:pic>
+        <p:nvPicPr>
+          <p:cNvPr id="18" name="Picture 17">
+            <a:extLst>
+              <a:ext uri="{FF2B5EF4-FFF2-40B4-BE49-F238E27FC236}">
+                <a16:creationId xmlns:a16="http://schemas.microsoft.com/office/drawing/2014/main" id="{BB22A295-45CB-0395-F0F9-F380A8B14286}"/>
+              </a:ext>
+            </a:extLst>
+          </p:cNvPr>
+          <p:cNvPicPr>
+            <a:picLocks noChangeAspect="1"/>
+          </p:cNvPicPr>
+          <p:nvPr/>
+        </p:nvPicPr>
+        <p:blipFill>
+          <a:blip r:embed="rId2"/>
+          <a:stretch>
+            <a:fillRect/>
+          </a:stretch>
+        </p:blipFill>
+        <p:spPr>
+          <a:xfrm>
+            <a:off x="3803030" y="2267712"/>
+            <a:ext cx="4563501" cy="4052807"/>
+          </a:xfrm>
+          <a:prstGeom prst="rect">
+            <a:avLst/>
+          </a:prstGeom>
+        </p:spPr>
+      </p:pic>
     </p:spTree>
   </p:cSld>
   <p:clrMapOvr>
@@ -9239,7 +8873,7 @@
             <a:avLst/>
           </a:prstGeom>
           <a:solidFill>
-            <a:srgbClr val="F8F5F2"/>
+            <a:srgbClr val="0B1220"/>
           </a:solidFill>
           <a:ln>
             <a:noFill/>
@@ -9265,7 +8899,7 @@
           <a:lstStyle/>
           <a:p>
             <a:pPr algn="ctr"/>
-            <a:endParaRPr dirty="0"/>
+            <a:endParaRPr/>
           </a:p>
         </p:txBody>
       </p:sp>
@@ -9277,8 +8911,8 @@
         </p:nvSpPr>
         <p:spPr>
           <a:xfrm>
-            <a:off x="640080" y="548640"/>
-            <a:ext cx="5486400" cy="365760"/>
+            <a:off x="640080" y="457200"/>
+            <a:ext cx="5486400" cy="320040"/>
           </a:xfrm>
           <a:prstGeom prst="rect">
             <a:avLst/>
@@ -9293,13 +8927,13 @@
           <a:p>
             <a:pPr algn="l"/>
             <a:r>
-              <a:rPr sz="1100" b="1" dirty="0">
+              <a:rPr sz="1100" b="1">
                 <a:solidFill>
                   <a:srgbClr val="E11D48"/>
                 </a:solidFill>
                 <a:latin typeface="Calibri"/>
               </a:rPr>
-              <a:t>07  /  ROADMAP</a:t>
+              <a:t>DEVELOPMENT PROCESS</a:t>
             </a:r>
           </a:p>
         </p:txBody>
@@ -9312,8 +8946,8 @@
         </p:nvSpPr>
         <p:spPr>
           <a:xfrm>
-            <a:off x="640080" y="914400"/>
-            <a:ext cx="10058400" cy="914400"/>
+            <a:off x="640080" y="777240"/>
+            <a:ext cx="10972800" cy="914400"/>
           </a:xfrm>
           <a:prstGeom prst="rect">
             <a:avLst/>
@@ -9328,35 +8962,33 @@
           <a:p>
             <a:pPr algn="l"/>
             <a:r>
-              <a:rPr sz="5400" b="1" dirty="0">
-                <a:solidFill>
-                  <a:srgbClr val="0F172A"/>
-                </a:solidFill>
-                <a:latin typeface="Calibri"/>
-              </a:rPr>
-              <a:t>Future steps</a:t>
-            </a:r>
-          </a:p>
-        </p:txBody>
-      </p:sp>
-      <p:sp>
-        <p:nvSpPr>
-          <p:cNvPr id="5" name="Rounded Rectangle 4"/>
+              <a:rPr sz="5200" b="1">
+                <a:solidFill>
+                  <a:srgbClr val="F8F5F2"/>
+                </a:solidFill>
+                <a:latin typeface="Calibri"/>
+              </a:rPr>
+              <a:t>Development stages</a:t>
+            </a:r>
+          </a:p>
+        </p:txBody>
+      </p:sp>
+      <p:sp>
+        <p:nvSpPr>
+          <p:cNvPr id="5" name="Rectangle 4"/>
           <p:cNvSpPr/>
           <p:nvPr/>
         </p:nvSpPr>
         <p:spPr>
           <a:xfrm>
-            <a:off x="640080" y="2468880"/>
-            <a:ext cx="10972800" cy="914400"/>
-          </a:xfrm>
-          <a:prstGeom prst="roundRect">
-            <a:avLst>
-              <a:gd name="adj" fmla="val 6000"/>
-            </a:avLst>
+            <a:off x="1731233" y="2788920"/>
+            <a:ext cx="8729228" cy="22860"/>
+          </a:xfrm>
+          <a:prstGeom prst="rect">
+            <a:avLst/>
           </a:prstGeom>
           <a:solidFill>
-            <a:srgbClr val="FFFFFF"/>
+            <a:srgbClr val="263246"/>
           </a:solidFill>
           <a:ln>
             <a:noFill/>
@@ -9382,20 +9014,67 @@
           <a:lstStyle/>
           <a:p>
             <a:pPr algn="ctr"/>
-            <a:endParaRPr dirty="0"/>
-          </a:p>
-        </p:txBody>
-      </p:sp>
-      <p:sp>
-        <p:nvSpPr>
-          <p:cNvPr id="6" name="TextBox 5"/>
+            <a:endParaRPr/>
+          </a:p>
+        </p:txBody>
+      </p:sp>
+      <p:sp>
+        <p:nvSpPr>
+          <p:cNvPr id="6" name="Oval 5"/>
+          <p:cNvSpPr/>
+          <p:nvPr/>
+        </p:nvSpPr>
+        <p:spPr>
+          <a:xfrm>
+            <a:off x="1402049" y="1874519"/>
+            <a:ext cx="658368" cy="658368"/>
+          </a:xfrm>
+          <a:prstGeom prst="ellipse">
+            <a:avLst/>
+          </a:prstGeom>
+          <a:solidFill>
+            <a:srgbClr val="1A2332"/>
+          </a:solidFill>
+          <a:ln w="25400">
+            <a:solidFill>
+              <a:srgbClr val="E11D48"/>
+            </a:solidFill>
+          </a:ln>
+          <a:effectLst/>
+        </p:spPr>
+        <p:style>
+          <a:lnRef idx="1">
+            <a:schemeClr val="accent1"/>
+          </a:lnRef>
+          <a:fillRef idx="3">
+            <a:schemeClr val="accent1"/>
+          </a:fillRef>
+          <a:effectRef idx="2">
+            <a:schemeClr val="accent1"/>
+          </a:effectRef>
+          <a:fontRef idx="minor">
+            <a:schemeClr val="lt1"/>
+          </a:fontRef>
+        </p:style>
+        <p:txBody>
+          <a:bodyPr rtlCol="0" anchor="ctr"/>
+          <a:lstStyle/>
+          <a:p>
+            <a:pPr algn="ctr"/>
+            <a:endParaRPr/>
+          </a:p>
+        </p:txBody>
+      </p:sp>
+      <p:sp>
+        <p:nvSpPr>
+          <p:cNvPr id="7" name="TextBox 6"/>
           <p:cNvSpPr txBox="1"/>
           <p:nvPr/>
         </p:nvSpPr>
         <p:spPr>
           <a:xfrm>
-            <a:off x="822960" y="2560320"/>
-            <a:ext cx="914400" cy="731520"/>
+            <a:off x="1402049" y="1874519"/>
+            <a:ext cx="658368" cy="658368"/>
           </a:xfrm>
           <a:prstGeom prst="rect">
             <a:avLst/>
@@ -9408,9 +9087,9 @@
           </a:bodyPr>
           <a:lstStyle/>
           <a:p>
-            <a:pPr algn="l"/>
-            <a:r>
-              <a:rPr sz="3200" b="1" dirty="0">
+            <a:pPr algn="ctr"/>
+            <a:r>
+              <a:rPr sz="2000" b="1">
                 <a:solidFill>
                   <a:srgbClr val="E11D48"/>
                 </a:solidFill>
@@ -9423,20 +9102,20 @@
       </p:sp>
       <p:sp>
         <p:nvSpPr>
-          <p:cNvPr id="7" name="Rectangle 6"/>
+          <p:cNvPr id="8" name="Oval 7"/>
           <p:cNvSpPr/>
           <p:nvPr/>
         </p:nvSpPr>
         <p:spPr>
           <a:xfrm>
-            <a:off x="1737360" y="2651760"/>
-            <a:ext cx="18288" cy="548640"/>
-          </a:xfrm>
-          <a:prstGeom prst="rect">
+            <a:off x="1648937" y="2706624"/>
+            <a:ext cx="164592" cy="164592"/>
+          </a:xfrm>
+          <a:prstGeom prst="ellipse">
             <a:avLst/>
           </a:prstGeom>
           <a:solidFill>
-            <a:srgbClr val="E8E2DD"/>
+            <a:srgbClr val="E11D48"/>
           </a:solidFill>
           <a:ln>
             <a:noFill/>
@@ -9462,98 +9141,26 @@
           <a:lstStyle/>
           <a:p>
             <a:pPr algn="ctr"/>
-            <a:endParaRPr dirty="0"/>
-          </a:p>
-        </p:txBody>
-      </p:sp>
-      <p:sp>
-        <p:nvSpPr>
-          <p:cNvPr id="8" name="TextBox 7"/>
-          <p:cNvSpPr txBox="1"/>
-          <p:nvPr/>
-        </p:nvSpPr>
-        <p:spPr>
-          <a:xfrm>
-            <a:off x="1965960" y="2633472"/>
-            <a:ext cx="9144000" cy="365760"/>
-          </a:xfrm>
-          <a:prstGeom prst="rect">
-            <a:avLst/>
-          </a:prstGeom>
-          <a:noFill/>
-        </p:spPr>
-        <p:txBody>
-          <a:bodyPr wrap="square" lIns="0" tIns="0" rIns="0" bIns="0" anchor="t">
-            <a:spAutoFit/>
-          </a:bodyPr>
-          <a:lstStyle/>
-          <a:p>
-            <a:pPr algn="l"/>
-            <a:r>
-              <a:rPr sz="1800" b="1" dirty="0">
-                <a:solidFill>
-                  <a:srgbClr val="0F172A"/>
-                </a:solidFill>
-                <a:latin typeface="Calibri"/>
-              </a:rPr>
-              <a:t>Payments &amp; deposits</a:t>
-            </a:r>
-          </a:p>
-        </p:txBody>
-      </p:sp>
-      <p:sp>
-        <p:nvSpPr>
-          <p:cNvPr id="9" name="TextBox 8"/>
-          <p:cNvSpPr txBox="1"/>
-          <p:nvPr/>
-        </p:nvSpPr>
-        <p:spPr>
-          <a:xfrm>
-            <a:off x="1965960" y="2971800"/>
-            <a:ext cx="9144000" cy="365760"/>
-          </a:xfrm>
-          <a:prstGeom prst="rect">
-            <a:avLst/>
-          </a:prstGeom>
-          <a:noFill/>
-        </p:spPr>
-        <p:txBody>
-          <a:bodyPr wrap="square" lIns="0" tIns="0" rIns="0" bIns="0" anchor="t">
-            <a:spAutoFit/>
-          </a:bodyPr>
-          <a:lstStyle/>
-          <a:p>
-            <a:pPr algn="l"/>
-            <a:r>
-              <a:rPr sz="1200" b="0" dirty="0">
-                <a:solidFill>
-                  <a:srgbClr val="64748B"/>
-                </a:solidFill>
-                <a:latin typeface="Calibri"/>
-              </a:rPr>
-              <a:t>Stripe-powered booking deposits with refundable holds and owner payouts.</a:t>
-            </a:r>
-          </a:p>
-        </p:txBody>
-      </p:sp>
-      <p:sp>
-        <p:nvSpPr>
-          <p:cNvPr id="10" name="Rounded Rectangle 9"/>
+            <a:endParaRPr/>
+          </a:p>
+        </p:txBody>
+      </p:sp>
+      <p:sp>
+        <p:nvSpPr>
+          <p:cNvPr id="9" name="Rectangle 8"/>
           <p:cNvSpPr/>
           <p:nvPr/>
         </p:nvSpPr>
         <p:spPr>
           <a:xfrm>
-            <a:off x="640080" y="3474720"/>
-            <a:ext cx="10972800" cy="914400"/>
-          </a:xfrm>
-          <a:prstGeom prst="roundRect">
-            <a:avLst>
-              <a:gd name="adj" fmla="val 6000"/>
-            </a:avLst>
+            <a:off x="1717517" y="2532887"/>
+            <a:ext cx="27432" cy="256033"/>
+          </a:xfrm>
+          <a:prstGeom prst="rect">
+            <a:avLst/>
           </a:prstGeom>
           <a:solidFill>
-            <a:srgbClr val="FFFFFF"/>
+            <a:srgbClr val="263246"/>
           </a:solidFill>
           <a:ln>
             <a:noFill/>
@@ -9579,7 +9186,54 @@
           <a:lstStyle/>
           <a:p>
             <a:pPr algn="ctr"/>
-            <a:endParaRPr dirty="0"/>
+            <a:endParaRPr/>
+          </a:p>
+        </p:txBody>
+      </p:sp>
+      <p:sp>
+        <p:nvSpPr>
+          <p:cNvPr id="10" name="TextBox 9"/>
+          <p:cNvSpPr txBox="1"/>
+          <p:nvPr/>
+        </p:nvSpPr>
+        <p:spPr>
+          <a:xfrm>
+            <a:off x="731520" y="3794760"/>
+            <a:ext cx="1999427" cy="822960"/>
+          </a:xfrm>
+          <a:prstGeom prst="rect">
+            <a:avLst/>
+          </a:prstGeom>
+          <a:noFill/>
+        </p:spPr>
+        <p:txBody>
+          <a:bodyPr wrap="square" lIns="0" tIns="0" rIns="0" bIns="0" anchor="t">
+            <a:spAutoFit/>
+          </a:bodyPr>
+          <a:lstStyle/>
+          <a:p>
+            <a:pPr algn="ctr"/>
+            <a:r>
+              <a:rPr sz="1600" b="1">
+                <a:solidFill>
+                  <a:srgbClr val="F8F5F2"/>
+                </a:solidFill>
+                <a:latin typeface="Calibri"/>
+              </a:rPr>
+              <a:t>Domain</a:t>
+            </a:r>
+          </a:p>
+          <a:p>
+            <a:pPr algn="ctr"/>
+            <a:r>
+              <a:rPr sz="1600" b="1">
+                <a:solidFill>
+                  <a:srgbClr val="F8F5F2"/>
+                </a:solidFill>
+                <a:latin typeface="Calibri"/>
+              </a:rPr>
+              <a:t>Model</a:t>
+            </a:r>
           </a:p>
         </p:txBody>
       </p:sp>
@@ -9591,8 +9245,114 @@
         </p:nvSpPr>
         <p:spPr>
           <a:xfrm>
-            <a:off x="822960" y="3566160"/>
-            <a:ext cx="914400" cy="731520"/>
+            <a:off x="731520" y="4663440"/>
+            <a:ext cx="1999427" cy="1188720"/>
+          </a:xfrm>
+          <a:prstGeom prst="rect">
+            <a:avLst/>
+          </a:prstGeom>
+          <a:noFill/>
+        </p:spPr>
+        <p:txBody>
+          <a:bodyPr wrap="square" lIns="0" tIns="0" rIns="0" bIns="0" anchor="t">
+            <a:spAutoFit/>
+          </a:bodyPr>
+          <a:lstStyle/>
+          <a:p>
+            <a:pPr algn="ctr"/>
+            <a:r>
+              <a:rPr sz="1200" b="0">
+                <a:solidFill>
+                  <a:srgbClr val="A0AEC0"/>
+                </a:solidFill>
+                <a:latin typeface="Calibri"/>
+              </a:rPr>
+              <a:t>Entities, value objects</a:t>
+            </a:r>
+          </a:p>
+          <a:p>
+            <a:pPr algn="ctr"/>
+            <a:r>
+              <a:rPr sz="1200" b="0">
+                <a:solidFill>
+                  <a:srgbClr val="A0AEC0"/>
+                </a:solidFill>
+                <a:latin typeface="Calibri"/>
+              </a:rPr>
+              <a:t>and business rules</a:t>
+            </a:r>
+          </a:p>
+          <a:p>
+            <a:pPr algn="ctr"/>
+            <a:r>
+              <a:rPr sz="1200" b="0">
+                <a:solidFill>
+                  <a:srgbClr val="A0AEC0"/>
+                </a:solidFill>
+                <a:latin typeface="Calibri"/>
+              </a:rPr>
+              <a:t>with DDD</a:t>
+            </a:r>
+          </a:p>
+        </p:txBody>
+      </p:sp>
+      <p:sp>
+        <p:nvSpPr>
+          <p:cNvPr id="12" name="Oval 11"/>
+          <p:cNvSpPr/>
+          <p:nvPr/>
+        </p:nvSpPr>
+        <p:spPr>
+          <a:xfrm>
+            <a:off x="3584356" y="1874519"/>
+            <a:ext cx="658368" cy="658368"/>
+          </a:xfrm>
+          <a:prstGeom prst="ellipse">
+            <a:avLst/>
+          </a:prstGeom>
+          <a:solidFill>
+            <a:srgbClr val="1A2332"/>
+          </a:solidFill>
+          <a:ln w="25400">
+            <a:solidFill>
+              <a:srgbClr val="E11D48"/>
+            </a:solidFill>
+          </a:ln>
+          <a:effectLst/>
+        </p:spPr>
+        <p:style>
+          <a:lnRef idx="1">
+            <a:schemeClr val="accent1"/>
+          </a:lnRef>
+          <a:fillRef idx="3">
+            <a:schemeClr val="accent1"/>
+          </a:fillRef>
+          <a:effectRef idx="2">
+            <a:schemeClr val="accent1"/>
+          </a:effectRef>
+          <a:fontRef idx="minor">
+            <a:schemeClr val="lt1"/>
+          </a:fontRef>
+        </p:style>
+        <p:txBody>
+          <a:bodyPr rtlCol="0" anchor="ctr"/>
+          <a:lstStyle/>
+          <a:p>
+            <a:pPr algn="ctr"/>
+            <a:endParaRPr/>
+          </a:p>
+        </p:txBody>
+      </p:sp>
+      <p:sp>
+        <p:nvSpPr>
+          <p:cNvPr id="13" name="TextBox 12"/>
+          <p:cNvSpPr txBox="1"/>
+          <p:nvPr/>
+        </p:nvSpPr>
+        <p:spPr>
+          <a:xfrm>
+            <a:off x="3584356" y="1874519"/>
+            <a:ext cx="658368" cy="658368"/>
           </a:xfrm>
           <a:prstGeom prst="rect">
             <a:avLst/>
@@ -9605,9 +9365,9 @@
           </a:bodyPr>
           <a:lstStyle/>
           <a:p>
-            <a:pPr algn="l"/>
-            <a:r>
-              <a:rPr sz="3200" b="1" dirty="0">
+            <a:pPr algn="ctr"/>
+            <a:r>
+              <a:rPr sz="2000" b="1">
                 <a:solidFill>
                   <a:srgbClr val="E11D48"/>
                 </a:solidFill>
@@ -9620,20 +9380,20 @@
       </p:sp>
       <p:sp>
         <p:nvSpPr>
-          <p:cNvPr id="12" name="Rectangle 11"/>
+          <p:cNvPr id="14" name="Oval 13"/>
           <p:cNvSpPr/>
           <p:nvPr/>
         </p:nvSpPr>
         <p:spPr>
           <a:xfrm>
-            <a:off x="1737360" y="3657600"/>
-            <a:ext cx="18288" cy="548640"/>
-          </a:xfrm>
-          <a:prstGeom prst="rect">
+            <a:off x="3831244" y="2706624"/>
+            <a:ext cx="164592" cy="164592"/>
+          </a:xfrm>
+          <a:prstGeom prst="ellipse">
             <a:avLst/>
           </a:prstGeom>
           <a:solidFill>
-            <a:srgbClr val="E8E2DD"/>
+            <a:srgbClr val="E11D48"/>
           </a:solidFill>
           <a:ln>
             <a:noFill/>
@@ -9659,111 +9419,26 @@
           <a:lstStyle/>
           <a:p>
             <a:pPr algn="ctr"/>
-            <a:endParaRPr dirty="0"/>
-          </a:p>
-        </p:txBody>
-      </p:sp>
-      <p:sp>
-        <p:nvSpPr>
-          <p:cNvPr id="13" name="TextBox 12"/>
-          <p:cNvSpPr txBox="1"/>
-          <p:nvPr/>
-        </p:nvSpPr>
-        <p:spPr>
-          <a:xfrm>
-            <a:off x="1965960" y="3639312"/>
-            <a:ext cx="9144000" cy="276999"/>
-          </a:xfrm>
-          <a:prstGeom prst="rect">
-            <a:avLst/>
-          </a:prstGeom>
-          <a:noFill/>
-        </p:spPr>
-        <p:txBody>
-          <a:bodyPr wrap="square" lIns="0" tIns="0" rIns="0" bIns="0" anchor="t">
-            <a:spAutoFit/>
-          </a:bodyPr>
-          <a:lstStyle/>
-          <a:p>
-            <a:r>
-              <a:rPr lang="en-US" b="1" dirty="0">
-                <a:solidFill>
-                  <a:srgbClr val="0F172A"/>
-                </a:solidFill>
-                <a:latin typeface="Calibri"/>
-              </a:rPr>
-              <a:t>Reviews &amp; ratings</a:t>
-            </a:r>
-            <a:endParaRPr b="1" dirty="0">
-              <a:solidFill>
-                <a:srgbClr val="0F172A"/>
-              </a:solidFill>
-              <a:latin typeface="Calibri"/>
-            </a:endParaRPr>
-          </a:p>
-        </p:txBody>
-      </p:sp>
-      <p:sp>
-        <p:nvSpPr>
-          <p:cNvPr id="14" name="TextBox 13"/>
-          <p:cNvSpPr txBox="1"/>
-          <p:nvPr/>
-        </p:nvSpPr>
-        <p:spPr>
-          <a:xfrm>
-            <a:off x="1965960" y="3977640"/>
-            <a:ext cx="9144000" cy="184666"/>
-          </a:xfrm>
-          <a:prstGeom prst="rect">
-            <a:avLst/>
-          </a:prstGeom>
-          <a:noFill/>
-        </p:spPr>
-        <p:txBody>
-          <a:bodyPr wrap="square" lIns="0" tIns="0" rIns="0" bIns="0" anchor="t">
-            <a:spAutoFit/>
-          </a:bodyPr>
-          <a:lstStyle/>
-          <a:p>
-            <a:r>
-              <a:rPr lang="en-US" sz="1200" dirty="0">
-                <a:solidFill>
-                  <a:srgbClr val="64748B"/>
-                </a:solidFill>
-                <a:latin typeface="Calibri"/>
-              </a:rPr>
-              <a:t>Let renters leave reviews for listings and owners after a viewing or stay</a:t>
-            </a:r>
-            <a:r>
-              <a:rPr sz="1200" dirty="0">
-                <a:solidFill>
-                  <a:srgbClr val="64748B"/>
-                </a:solidFill>
-                <a:latin typeface="Calibri"/>
-              </a:rPr>
-              <a:t>.</a:t>
-            </a:r>
-          </a:p>
-        </p:txBody>
-      </p:sp>
-      <p:sp>
-        <p:nvSpPr>
-          <p:cNvPr id="15" name="Rounded Rectangle 14"/>
+            <a:endParaRPr/>
+          </a:p>
+        </p:txBody>
+      </p:sp>
+      <p:sp>
+        <p:nvSpPr>
+          <p:cNvPr id="15" name="Rectangle 14"/>
           <p:cNvSpPr/>
           <p:nvPr/>
         </p:nvSpPr>
         <p:spPr>
           <a:xfrm>
-            <a:off x="640080" y="4480560"/>
-            <a:ext cx="10972800" cy="914400"/>
-          </a:xfrm>
-          <a:prstGeom prst="roundRect">
-            <a:avLst>
-              <a:gd name="adj" fmla="val 6000"/>
-            </a:avLst>
+            <a:off x="3899824" y="2532887"/>
+            <a:ext cx="27432" cy="256033"/>
+          </a:xfrm>
+          <a:prstGeom prst="rect">
+            <a:avLst/>
           </a:prstGeom>
           <a:solidFill>
-            <a:srgbClr val="FFFFFF"/>
+            <a:srgbClr val="263246"/>
           </a:solidFill>
           <a:ln>
             <a:noFill/>
@@ -9789,7 +9464,7 @@
           <a:lstStyle/>
           <a:p>
             <a:pPr algn="ctr"/>
-            <a:endParaRPr dirty="0"/>
+            <a:endParaRPr/>
           </a:p>
         </p:txBody>
       </p:sp>
@@ -9801,8 +9476,161 @@
         </p:nvSpPr>
         <p:spPr>
           <a:xfrm>
-            <a:off x="822960" y="4572000"/>
-            <a:ext cx="914400" cy="731520"/>
+            <a:off x="2913827" y="3794760"/>
+            <a:ext cx="1999427" cy="822960"/>
+          </a:xfrm>
+          <a:prstGeom prst="rect">
+            <a:avLst/>
+          </a:prstGeom>
+          <a:noFill/>
+        </p:spPr>
+        <p:txBody>
+          <a:bodyPr wrap="square" lIns="0" tIns="0" rIns="0" bIns="0" anchor="t">
+            <a:spAutoFit/>
+          </a:bodyPr>
+          <a:lstStyle/>
+          <a:p>
+            <a:pPr algn="ctr"/>
+            <a:r>
+              <a:rPr sz="1600" b="1">
+                <a:solidFill>
+                  <a:srgbClr val="F8F5F2"/>
+                </a:solidFill>
+                <a:latin typeface="Calibri"/>
+              </a:rPr>
+              <a:t>API</a:t>
+            </a:r>
+          </a:p>
+          <a:p>
+            <a:pPr algn="ctr"/>
+            <a:r>
+              <a:rPr sz="1600" b="1">
+                <a:solidFill>
+                  <a:srgbClr val="F8F5F2"/>
+                </a:solidFill>
+                <a:latin typeface="Calibri"/>
+              </a:rPr>
+              <a:t>Design</a:t>
+            </a:r>
+          </a:p>
+        </p:txBody>
+      </p:sp>
+      <p:sp>
+        <p:nvSpPr>
+          <p:cNvPr id="17" name="TextBox 16"/>
+          <p:cNvSpPr txBox="1"/>
+          <p:nvPr/>
+        </p:nvSpPr>
+        <p:spPr>
+          <a:xfrm>
+            <a:off x="2913827" y="4663440"/>
+            <a:ext cx="1999427" cy="1188720"/>
+          </a:xfrm>
+          <a:prstGeom prst="rect">
+            <a:avLst/>
+          </a:prstGeom>
+          <a:noFill/>
+        </p:spPr>
+        <p:txBody>
+          <a:bodyPr wrap="square" lIns="0" tIns="0" rIns="0" bIns="0" anchor="t">
+            <a:spAutoFit/>
+          </a:bodyPr>
+          <a:lstStyle/>
+          <a:p>
+            <a:pPr algn="ctr"/>
+            <a:r>
+              <a:rPr sz="1200" b="0">
+                <a:solidFill>
+                  <a:srgbClr val="A0AEC0"/>
+                </a:solidFill>
+                <a:latin typeface="Calibri"/>
+              </a:rPr>
+              <a:t>OpenAPI spec, REST</a:t>
+            </a:r>
+          </a:p>
+          <a:p>
+            <a:pPr algn="ctr"/>
+            <a:r>
+              <a:rPr sz="1200" b="0">
+                <a:solidFill>
+                  <a:srgbClr val="A0AEC0"/>
+                </a:solidFill>
+                <a:latin typeface="Calibri"/>
+              </a:rPr>
+              <a:t>endpoints and</a:t>
+            </a:r>
+          </a:p>
+          <a:p>
+            <a:pPr algn="ctr"/>
+            <a:r>
+              <a:rPr sz="1200" b="0">
+                <a:solidFill>
+                  <a:srgbClr val="A0AEC0"/>
+                </a:solidFill>
+                <a:latin typeface="Calibri"/>
+              </a:rPr>
+              <a:t>MapStruct DTOs</a:t>
+            </a:r>
+          </a:p>
+        </p:txBody>
+      </p:sp>
+      <p:sp>
+        <p:nvSpPr>
+          <p:cNvPr id="18" name="Oval 17"/>
+          <p:cNvSpPr/>
+          <p:nvPr/>
+        </p:nvSpPr>
+        <p:spPr>
+          <a:xfrm>
+            <a:off x="5766663" y="1874519"/>
+            <a:ext cx="658368" cy="658368"/>
+          </a:xfrm>
+          <a:prstGeom prst="ellipse">
+            <a:avLst/>
+          </a:prstGeom>
+          <a:solidFill>
+            <a:srgbClr val="1A2332"/>
+          </a:solidFill>
+          <a:ln w="25400">
+            <a:solidFill>
+              <a:srgbClr val="E11D48"/>
+            </a:solidFill>
+          </a:ln>
+          <a:effectLst/>
+        </p:spPr>
+        <p:style>
+          <a:lnRef idx="1">
+            <a:schemeClr val="accent1"/>
+          </a:lnRef>
+          <a:fillRef idx="3">
+            <a:schemeClr val="accent1"/>
+          </a:fillRef>
+          <a:effectRef idx="2">
+            <a:schemeClr val="accent1"/>
+          </a:effectRef>
+          <a:fontRef idx="minor">
+            <a:schemeClr val="lt1"/>
+          </a:fontRef>
+        </p:style>
+        <p:txBody>
+          <a:bodyPr rtlCol="0" anchor="ctr"/>
+          <a:lstStyle/>
+          <a:p>
+            <a:pPr algn="ctr"/>
+            <a:endParaRPr/>
+          </a:p>
+        </p:txBody>
+      </p:sp>
+      <p:sp>
+        <p:nvSpPr>
+          <p:cNvPr id="19" name="TextBox 18"/>
+          <p:cNvSpPr txBox="1"/>
+          <p:nvPr/>
+        </p:nvSpPr>
+        <p:spPr>
+          <a:xfrm>
+            <a:off x="5766663" y="1874519"/>
+            <a:ext cx="658368" cy="658368"/>
           </a:xfrm>
           <a:prstGeom prst="rect">
             <a:avLst/>
@@ -9815,9 +9643,9 @@
           </a:bodyPr>
           <a:lstStyle/>
           <a:p>
-            <a:pPr algn="l"/>
-            <a:r>
-              <a:rPr sz="3200" b="1" dirty="0">
+            <a:pPr algn="ctr"/>
+            <a:r>
+              <a:rPr sz="2000" b="1">
                 <a:solidFill>
                   <a:srgbClr val="E11D48"/>
                 </a:solidFill>
@@ -9830,20 +9658,20 @@
       </p:sp>
       <p:sp>
         <p:nvSpPr>
-          <p:cNvPr id="17" name="Rectangle 16"/>
+          <p:cNvPr id="20" name="Oval 19"/>
           <p:cNvSpPr/>
           <p:nvPr/>
         </p:nvSpPr>
         <p:spPr>
           <a:xfrm>
-            <a:off x="1737360" y="4663440"/>
-            <a:ext cx="18288" cy="548640"/>
-          </a:xfrm>
-          <a:prstGeom prst="rect">
+            <a:off x="6013551" y="2706624"/>
+            <a:ext cx="164592" cy="164592"/>
+          </a:xfrm>
+          <a:prstGeom prst="ellipse">
             <a:avLst/>
           </a:prstGeom>
           <a:solidFill>
-            <a:srgbClr val="E8E2DD"/>
+            <a:srgbClr val="E11D48"/>
           </a:solidFill>
           <a:ln>
             <a:noFill/>
@@ -9869,20 +9697,65 @@
           <a:lstStyle/>
           <a:p>
             <a:pPr algn="ctr"/>
-            <a:endParaRPr dirty="0"/>
-          </a:p>
-        </p:txBody>
-      </p:sp>
-      <p:sp>
-        <p:nvSpPr>
-          <p:cNvPr id="18" name="TextBox 17"/>
+            <a:endParaRPr/>
+          </a:p>
+        </p:txBody>
+      </p:sp>
+      <p:sp>
+        <p:nvSpPr>
+          <p:cNvPr id="21" name="Rectangle 20"/>
+          <p:cNvSpPr/>
+          <p:nvPr/>
+        </p:nvSpPr>
+        <p:spPr>
+          <a:xfrm>
+            <a:off x="6082131" y="2532887"/>
+            <a:ext cx="27432" cy="256033"/>
+          </a:xfrm>
+          <a:prstGeom prst="rect">
+            <a:avLst/>
+          </a:prstGeom>
+          <a:solidFill>
+            <a:srgbClr val="263246"/>
+          </a:solidFill>
+          <a:ln>
+            <a:noFill/>
+          </a:ln>
+          <a:effectLst/>
+        </p:spPr>
+        <p:style>
+          <a:lnRef idx="1">
+            <a:schemeClr val="accent1"/>
+          </a:lnRef>
+          <a:fillRef idx="3">
+            <a:schemeClr val="accent1"/>
+          </a:fillRef>
+          <a:effectRef idx="2">
+            <a:schemeClr val="accent1"/>
+          </a:effectRef>
+          <a:fontRef idx="minor">
+            <a:schemeClr val="lt1"/>
+          </a:fontRef>
+        </p:style>
+        <p:txBody>
+          <a:bodyPr rtlCol="0" anchor="ctr"/>
+          <a:lstStyle/>
+          <a:p>
+            <a:pPr algn="ctr"/>
+            <a:endParaRPr/>
+          </a:p>
+        </p:txBody>
+      </p:sp>
+      <p:sp>
+        <p:nvSpPr>
+          <p:cNvPr id="22" name="TextBox 21"/>
           <p:cNvSpPr txBox="1"/>
           <p:nvPr/>
         </p:nvSpPr>
         <p:spPr>
           <a:xfrm>
-            <a:off x="1965960" y="4645152"/>
-            <a:ext cx="9144000" cy="276999"/>
+            <a:off x="5096134" y="3794760"/>
+            <a:ext cx="1999427" cy="822960"/>
           </a:xfrm>
           <a:prstGeom prst="rect">
             <a:avLst/>
@@ -9895,34 +9768,550 @@
           </a:bodyPr>
           <a:lstStyle/>
           <a:p>
-            <a:r>
-              <a:rPr lang="en-US" b="1" dirty="0">
-                <a:solidFill>
-                  <a:srgbClr val="0F172A"/>
-                </a:solidFill>
-                <a:latin typeface="Calibri"/>
-              </a:rPr>
-              <a:t>Saved search alerts</a:t>
-            </a:r>
-            <a:endParaRPr b="1" dirty="0">
+            <a:pPr algn="ctr"/>
+            <a:r>
+              <a:rPr sz="1600" b="1">
+                <a:solidFill>
+                  <a:srgbClr val="F8F5F2"/>
+                </a:solidFill>
+                <a:latin typeface="Calibri"/>
+              </a:rPr>
+              <a:t>Back-end</a:t>
+            </a:r>
+          </a:p>
+        </p:txBody>
+      </p:sp>
+      <p:sp>
+        <p:nvSpPr>
+          <p:cNvPr id="23" name="TextBox 22"/>
+          <p:cNvSpPr txBox="1"/>
+          <p:nvPr/>
+        </p:nvSpPr>
+        <p:spPr>
+          <a:xfrm>
+            <a:off x="5096134" y="4663440"/>
+            <a:ext cx="1999427" cy="1188720"/>
+          </a:xfrm>
+          <a:prstGeom prst="rect">
+            <a:avLst/>
+          </a:prstGeom>
+          <a:noFill/>
+        </p:spPr>
+        <p:txBody>
+          <a:bodyPr wrap="square" lIns="0" tIns="0" rIns="0" bIns="0" anchor="t">
+            <a:spAutoFit/>
+          </a:bodyPr>
+          <a:lstStyle/>
+          <a:p>
+            <a:pPr algn="ctr"/>
+            <a:r>
+              <a:rPr sz="1200" b="0">
+                <a:solidFill>
+                  <a:srgbClr val="A0AEC0"/>
+                </a:solidFill>
+                <a:latin typeface="Calibri"/>
+              </a:rPr>
+              <a:t>Spring Boot 4, JPA,</a:t>
+            </a:r>
+          </a:p>
+          <a:p>
+            <a:pPr algn="ctr"/>
+            <a:r>
+              <a:rPr sz="1200" b="0">
+                <a:solidFill>
+                  <a:srgbClr val="A0AEC0"/>
+                </a:solidFill>
+                <a:latin typeface="Calibri"/>
+              </a:rPr>
+              <a:t>PostgreSQL, Liquibase</a:t>
+            </a:r>
+          </a:p>
+          <a:p>
+            <a:pPr algn="ctr"/>
+            <a:r>
+              <a:rPr sz="1200" b="0">
+                <a:solidFill>
+                  <a:srgbClr val="A0AEC0"/>
+                </a:solidFill>
+                <a:latin typeface="Calibri"/>
+              </a:rPr>
+              <a:t>and Keycloak auth</a:t>
+            </a:r>
+          </a:p>
+        </p:txBody>
+      </p:sp>
+      <p:sp>
+        <p:nvSpPr>
+          <p:cNvPr id="24" name="Oval 23"/>
+          <p:cNvSpPr/>
+          <p:nvPr/>
+        </p:nvSpPr>
+        <p:spPr>
+          <a:xfrm>
+            <a:off x="7948970" y="1874519"/>
+            <a:ext cx="658368" cy="658368"/>
+          </a:xfrm>
+          <a:prstGeom prst="ellipse">
+            <a:avLst/>
+          </a:prstGeom>
+          <a:solidFill>
+            <a:srgbClr val="1A2332"/>
+          </a:solidFill>
+          <a:ln w="25400">
+            <a:solidFill>
+              <a:srgbClr val="E11D48"/>
+            </a:solidFill>
+          </a:ln>
+          <a:effectLst/>
+        </p:spPr>
+        <p:style>
+          <a:lnRef idx="1">
+            <a:schemeClr val="accent1"/>
+          </a:lnRef>
+          <a:fillRef idx="3">
+            <a:schemeClr val="accent1"/>
+          </a:fillRef>
+          <a:effectRef idx="2">
+            <a:schemeClr val="accent1"/>
+          </a:effectRef>
+          <a:fontRef idx="minor">
+            <a:schemeClr val="lt1"/>
+          </a:fontRef>
+        </p:style>
+        <p:txBody>
+          <a:bodyPr rtlCol="0" anchor="ctr"/>
+          <a:lstStyle/>
+          <a:p>
+            <a:pPr algn="ctr"/>
+            <a:endParaRPr/>
+          </a:p>
+        </p:txBody>
+      </p:sp>
+      <p:sp>
+        <p:nvSpPr>
+          <p:cNvPr id="25" name="TextBox 24"/>
+          <p:cNvSpPr txBox="1"/>
+          <p:nvPr/>
+        </p:nvSpPr>
+        <p:spPr>
+          <a:xfrm>
+            <a:off x="7948970" y="1874519"/>
+            <a:ext cx="658368" cy="658368"/>
+          </a:xfrm>
+          <a:prstGeom prst="rect">
+            <a:avLst/>
+          </a:prstGeom>
+          <a:noFill/>
+        </p:spPr>
+        <p:txBody>
+          <a:bodyPr wrap="square" lIns="0" tIns="0" rIns="0" bIns="0" anchor="ctr">
+            <a:spAutoFit/>
+          </a:bodyPr>
+          <a:lstStyle/>
+          <a:p>
+            <a:pPr algn="ctr"/>
+            <a:r>
+              <a:rPr sz="2000" b="1">
+                <a:solidFill>
+                  <a:srgbClr val="E11D48"/>
+                </a:solidFill>
+                <a:latin typeface="Calibri"/>
+              </a:rPr>
+              <a:t>04</a:t>
+            </a:r>
+          </a:p>
+        </p:txBody>
+      </p:sp>
+      <p:sp>
+        <p:nvSpPr>
+          <p:cNvPr id="26" name="Oval 25"/>
+          <p:cNvSpPr/>
+          <p:nvPr/>
+        </p:nvSpPr>
+        <p:spPr>
+          <a:xfrm>
+            <a:off x="8195858" y="2706624"/>
+            <a:ext cx="164592" cy="164592"/>
+          </a:xfrm>
+          <a:prstGeom prst="ellipse">
+            <a:avLst/>
+          </a:prstGeom>
+          <a:solidFill>
+            <a:srgbClr val="E11D48"/>
+          </a:solidFill>
+          <a:ln>
+            <a:noFill/>
+          </a:ln>
+          <a:effectLst/>
+        </p:spPr>
+        <p:style>
+          <a:lnRef idx="1">
+            <a:schemeClr val="accent1"/>
+          </a:lnRef>
+          <a:fillRef idx="3">
+            <a:schemeClr val="accent1"/>
+          </a:fillRef>
+          <a:effectRef idx="2">
+            <a:schemeClr val="accent1"/>
+          </a:effectRef>
+          <a:fontRef idx="minor">
+            <a:schemeClr val="lt1"/>
+          </a:fontRef>
+        </p:style>
+        <p:txBody>
+          <a:bodyPr rtlCol="0" anchor="ctr"/>
+          <a:lstStyle/>
+          <a:p>
+            <a:pPr algn="ctr"/>
+            <a:endParaRPr/>
+          </a:p>
+        </p:txBody>
+      </p:sp>
+      <p:sp>
+        <p:nvSpPr>
+          <p:cNvPr id="27" name="Rectangle 26"/>
+          <p:cNvSpPr/>
+          <p:nvPr/>
+        </p:nvSpPr>
+        <p:spPr>
+          <a:xfrm>
+            <a:off x="8264438" y="2532887"/>
+            <a:ext cx="27432" cy="256033"/>
+          </a:xfrm>
+          <a:prstGeom prst="rect">
+            <a:avLst/>
+          </a:prstGeom>
+          <a:solidFill>
+            <a:srgbClr val="263246"/>
+          </a:solidFill>
+          <a:ln>
+            <a:noFill/>
+          </a:ln>
+          <a:effectLst/>
+        </p:spPr>
+        <p:style>
+          <a:lnRef idx="1">
+            <a:schemeClr val="accent1"/>
+          </a:lnRef>
+          <a:fillRef idx="3">
+            <a:schemeClr val="accent1"/>
+          </a:fillRef>
+          <a:effectRef idx="2">
+            <a:schemeClr val="accent1"/>
+          </a:effectRef>
+          <a:fontRef idx="minor">
+            <a:schemeClr val="lt1"/>
+          </a:fontRef>
+        </p:style>
+        <p:txBody>
+          <a:bodyPr rtlCol="0" anchor="ctr"/>
+          <a:lstStyle/>
+          <a:p>
+            <a:pPr algn="ctr"/>
+            <a:endParaRPr/>
+          </a:p>
+        </p:txBody>
+      </p:sp>
+      <p:sp>
+        <p:nvSpPr>
+          <p:cNvPr id="28" name="TextBox 27"/>
+          <p:cNvSpPr txBox="1"/>
+          <p:nvPr/>
+        </p:nvSpPr>
+        <p:spPr>
+          <a:xfrm>
+            <a:off x="7278441" y="3794760"/>
+            <a:ext cx="1999427" cy="822960"/>
+          </a:xfrm>
+          <a:prstGeom prst="rect">
+            <a:avLst/>
+          </a:prstGeom>
+          <a:noFill/>
+        </p:spPr>
+        <p:txBody>
+          <a:bodyPr wrap="square" lIns="0" tIns="0" rIns="0" bIns="0" anchor="t">
+            <a:spAutoFit/>
+          </a:bodyPr>
+          <a:lstStyle/>
+          <a:p>
+            <a:pPr algn="ctr"/>
+            <a:r>
+              <a:rPr sz="1600" b="1">
+                <a:solidFill>
+                  <a:srgbClr val="F8F5F2"/>
+                </a:solidFill>
+                <a:latin typeface="Calibri"/>
+              </a:rPr>
+              <a:t>Front-end</a:t>
+            </a:r>
+          </a:p>
+        </p:txBody>
+      </p:sp>
+      <p:sp>
+        <p:nvSpPr>
+          <p:cNvPr id="29" name="TextBox 28"/>
+          <p:cNvSpPr txBox="1"/>
+          <p:nvPr/>
+        </p:nvSpPr>
+        <p:spPr>
+          <a:xfrm>
+            <a:off x="7278441" y="4663440"/>
+            <a:ext cx="1999427" cy="553998"/>
+          </a:xfrm>
+          <a:prstGeom prst="rect">
+            <a:avLst/>
+          </a:prstGeom>
+          <a:noFill/>
+        </p:spPr>
+        <p:txBody>
+          <a:bodyPr wrap="square" lIns="0" tIns="0" rIns="0" bIns="0" anchor="t">
+            <a:spAutoFit/>
+          </a:bodyPr>
+          <a:lstStyle/>
+          <a:p>
+            <a:pPr algn="ctr"/>
+            <a:r>
+              <a:rPr sz="1200" b="0" dirty="0">
+                <a:solidFill>
+                  <a:srgbClr val="A0AEC0"/>
+                </a:solidFill>
+                <a:latin typeface="Calibri"/>
+              </a:rPr>
+              <a:t>Angular,</a:t>
+            </a:r>
+            <a:r>
+              <a:rPr lang="en-US" sz="1200" b="0" dirty="0">
+                <a:solidFill>
+                  <a:srgbClr val="A0AEC0"/>
+                </a:solidFill>
+                <a:latin typeface="Calibri"/>
+              </a:rPr>
+              <a:t> TS,</a:t>
+            </a:r>
+            <a:r>
+              <a:rPr lang="ru-RU" sz="1200" b="0" dirty="0">
+                <a:solidFill>
+                  <a:srgbClr val="A0AEC0"/>
+                </a:solidFill>
+                <a:latin typeface="Calibri"/>
+              </a:rPr>
+              <a:t> </a:t>
+            </a:r>
+            <a:endParaRPr sz="1200" b="0" dirty="0">
               <a:solidFill>
-                <a:srgbClr val="0F172A"/>
+                <a:srgbClr val="A0AEC0"/>
               </a:solidFill>
               <a:latin typeface="Calibri"/>
             </a:endParaRPr>
           </a:p>
-        </p:txBody>
-      </p:sp>
-      <p:sp>
-        <p:nvSpPr>
-          <p:cNvPr id="19" name="TextBox 18"/>
+          <a:p>
+            <a:pPr algn="ctr"/>
+            <a:r>
+              <a:rPr sz="1200" b="0" dirty="0">
+                <a:solidFill>
+                  <a:srgbClr val="A0AEC0"/>
+                </a:solidFill>
+                <a:latin typeface="Calibri"/>
+              </a:rPr>
+              <a:t>Reactive Forms</a:t>
+            </a:r>
+          </a:p>
+          <a:p>
+            <a:pPr algn="ctr"/>
+            <a:r>
+              <a:rPr sz="1200" b="0" dirty="0">
+                <a:solidFill>
+                  <a:srgbClr val="A0AEC0"/>
+                </a:solidFill>
+                <a:latin typeface="Calibri"/>
+              </a:rPr>
+              <a:t>and SCSS</a:t>
+            </a:r>
+          </a:p>
+        </p:txBody>
+      </p:sp>
+      <p:sp>
+        <p:nvSpPr>
+          <p:cNvPr id="30" name="Oval 29"/>
+          <p:cNvSpPr/>
+          <p:nvPr/>
+        </p:nvSpPr>
+        <p:spPr>
+          <a:xfrm>
+            <a:off x="10131277" y="1874519"/>
+            <a:ext cx="658368" cy="658368"/>
+          </a:xfrm>
+          <a:prstGeom prst="ellipse">
+            <a:avLst/>
+          </a:prstGeom>
+          <a:solidFill>
+            <a:srgbClr val="1A2332"/>
+          </a:solidFill>
+          <a:ln w="25400">
+            <a:solidFill>
+              <a:srgbClr val="E11D48"/>
+            </a:solidFill>
+          </a:ln>
+          <a:effectLst/>
+        </p:spPr>
+        <p:style>
+          <a:lnRef idx="1">
+            <a:schemeClr val="accent1"/>
+          </a:lnRef>
+          <a:fillRef idx="3">
+            <a:schemeClr val="accent1"/>
+          </a:fillRef>
+          <a:effectRef idx="2">
+            <a:schemeClr val="accent1"/>
+          </a:effectRef>
+          <a:fontRef idx="minor">
+            <a:schemeClr val="lt1"/>
+          </a:fontRef>
+        </p:style>
+        <p:txBody>
+          <a:bodyPr rtlCol="0" anchor="ctr"/>
+          <a:lstStyle/>
+          <a:p>
+            <a:pPr algn="ctr"/>
+            <a:endParaRPr dirty="0"/>
+          </a:p>
+        </p:txBody>
+      </p:sp>
+      <p:sp>
+        <p:nvSpPr>
+          <p:cNvPr id="31" name="TextBox 30"/>
           <p:cNvSpPr txBox="1"/>
           <p:nvPr/>
         </p:nvSpPr>
         <p:spPr>
           <a:xfrm>
-            <a:off x="1965960" y="4983480"/>
-            <a:ext cx="9144000" cy="184666"/>
+            <a:off x="10131277" y="1874519"/>
+            <a:ext cx="658368" cy="658368"/>
+          </a:xfrm>
+          <a:prstGeom prst="rect">
+            <a:avLst/>
+          </a:prstGeom>
+          <a:noFill/>
+        </p:spPr>
+        <p:txBody>
+          <a:bodyPr wrap="square" lIns="0" tIns="0" rIns="0" bIns="0" anchor="ctr">
+            <a:spAutoFit/>
+          </a:bodyPr>
+          <a:lstStyle/>
+          <a:p>
+            <a:pPr algn="ctr"/>
+            <a:r>
+              <a:rPr sz="2000" b="1" dirty="0">
+                <a:solidFill>
+                  <a:srgbClr val="E11D48"/>
+                </a:solidFill>
+                <a:latin typeface="Calibri"/>
+              </a:rPr>
+              <a:t>05</a:t>
+            </a:r>
+          </a:p>
+        </p:txBody>
+      </p:sp>
+      <p:sp>
+        <p:nvSpPr>
+          <p:cNvPr id="32" name="Oval 31"/>
+          <p:cNvSpPr/>
+          <p:nvPr/>
+        </p:nvSpPr>
+        <p:spPr>
+          <a:xfrm>
+            <a:off x="10378165" y="2706624"/>
+            <a:ext cx="164592" cy="164592"/>
+          </a:xfrm>
+          <a:prstGeom prst="ellipse">
+            <a:avLst/>
+          </a:prstGeom>
+          <a:solidFill>
+            <a:srgbClr val="E11D48"/>
+          </a:solidFill>
+          <a:ln>
+            <a:noFill/>
+          </a:ln>
+          <a:effectLst/>
+        </p:spPr>
+        <p:style>
+          <a:lnRef idx="1">
+            <a:schemeClr val="accent1"/>
+          </a:lnRef>
+          <a:fillRef idx="3">
+            <a:schemeClr val="accent1"/>
+          </a:fillRef>
+          <a:effectRef idx="2">
+            <a:schemeClr val="accent1"/>
+          </a:effectRef>
+          <a:fontRef idx="minor">
+            <a:schemeClr val="lt1"/>
+          </a:fontRef>
+        </p:style>
+        <p:txBody>
+          <a:bodyPr rtlCol="0" anchor="ctr"/>
+          <a:lstStyle/>
+          <a:p>
+            <a:pPr algn="ctr"/>
+            <a:endParaRPr dirty="0"/>
+          </a:p>
+        </p:txBody>
+      </p:sp>
+      <p:sp>
+        <p:nvSpPr>
+          <p:cNvPr id="33" name="Rectangle 32"/>
+          <p:cNvSpPr/>
+          <p:nvPr/>
+        </p:nvSpPr>
+        <p:spPr>
+          <a:xfrm>
+            <a:off x="10446745" y="2532887"/>
+            <a:ext cx="27432" cy="256033"/>
+          </a:xfrm>
+          <a:prstGeom prst="rect">
+            <a:avLst/>
+          </a:prstGeom>
+          <a:solidFill>
+            <a:srgbClr val="263246"/>
+          </a:solidFill>
+          <a:ln>
+            <a:noFill/>
+          </a:ln>
+          <a:effectLst/>
+        </p:spPr>
+        <p:style>
+          <a:lnRef idx="1">
+            <a:schemeClr val="accent1"/>
+          </a:lnRef>
+          <a:fillRef idx="3">
+            <a:schemeClr val="accent1"/>
+          </a:fillRef>
+          <a:effectRef idx="2">
+            <a:schemeClr val="accent1"/>
+          </a:effectRef>
+          <a:fontRef idx="minor">
+            <a:schemeClr val="lt1"/>
+          </a:fontRef>
+        </p:style>
+        <p:txBody>
+          <a:bodyPr rtlCol="0" anchor="ctr"/>
+          <a:lstStyle/>
+          <a:p>
+            <a:pPr algn="ctr"/>
+            <a:endParaRPr dirty="0"/>
+          </a:p>
+        </p:txBody>
+      </p:sp>
+      <p:sp>
+        <p:nvSpPr>
+          <p:cNvPr id="34" name="TextBox 33"/>
+          <p:cNvSpPr txBox="1"/>
+          <p:nvPr/>
+        </p:nvSpPr>
+        <p:spPr>
+          <a:xfrm>
+            <a:off x="9460748" y="3794760"/>
+            <a:ext cx="1999427" cy="822960"/>
           </a:xfrm>
           <a:prstGeom prst="rect">
             <a:avLst/>
@@ -9935,21 +10324,75 @@
           </a:bodyPr>
           <a:lstStyle/>
           <a:p>
-            <a:r>
-              <a:rPr lang="en-US" sz="1200" dirty="0">
-                <a:solidFill>
-                  <a:srgbClr val="64748B"/>
-                </a:solidFill>
-                <a:latin typeface="Calibri"/>
-              </a:rPr>
-              <a:t>Notify users when a new listing matches their saved search criteria.</a:t>
-            </a:r>
-            <a:endParaRPr sz="1200" dirty="0">
-              <a:solidFill>
-                <a:srgbClr val="64748B"/>
-              </a:solidFill>
-              <a:latin typeface="Calibri"/>
-            </a:endParaRPr>
+            <a:pPr algn="ctr"/>
+            <a:r>
+              <a:rPr sz="1600" b="1" dirty="0">
+                <a:solidFill>
+                  <a:srgbClr val="F8F5F2"/>
+                </a:solidFill>
+                <a:latin typeface="Calibri"/>
+              </a:rPr>
+              <a:t>Deploy</a:t>
+            </a:r>
+          </a:p>
+        </p:txBody>
+      </p:sp>
+      <p:sp>
+        <p:nvSpPr>
+          <p:cNvPr id="35" name="TextBox 34"/>
+          <p:cNvSpPr txBox="1"/>
+          <p:nvPr/>
+        </p:nvSpPr>
+        <p:spPr>
+          <a:xfrm>
+            <a:off x="9460748" y="4663440"/>
+            <a:ext cx="1999427" cy="1188720"/>
+          </a:xfrm>
+          <a:prstGeom prst="rect">
+            <a:avLst/>
+          </a:prstGeom>
+          <a:noFill/>
+        </p:spPr>
+        <p:txBody>
+          <a:bodyPr wrap="square" lIns="0" tIns="0" rIns="0" bIns="0" anchor="t">
+            <a:spAutoFit/>
+          </a:bodyPr>
+          <a:lstStyle/>
+          <a:p>
+            <a:pPr algn="ctr"/>
+            <a:r>
+              <a:rPr sz="1200" b="0" dirty="0">
+                <a:solidFill>
+                  <a:srgbClr val="A0AEC0"/>
+                </a:solidFill>
+                <a:latin typeface="Calibri"/>
+              </a:rPr>
+              <a:t>Docker, GitLab CI/CD,</a:t>
+            </a:r>
+          </a:p>
+          <a:p>
+            <a:pPr algn="ctr"/>
+            <a:r>
+              <a:rPr sz="1200" b="0" dirty="0">
+                <a:solidFill>
+                  <a:srgbClr val="A0AEC0"/>
+                </a:solidFill>
+                <a:latin typeface="Calibri"/>
+              </a:rPr>
+              <a:t>Azure ACR and</a:t>
+            </a:r>
+          </a:p>
+          <a:p>
+            <a:pPr algn="ctr"/>
+            <a:r>
+              <a:rPr sz="1200" b="0" dirty="0">
+                <a:solidFill>
+                  <a:srgbClr val="A0AEC0"/>
+                </a:solidFill>
+                <a:latin typeface="Calibri"/>
+              </a:rPr>
+              <a:t>Kubernetes rollout</a:t>
+            </a:r>
           </a:p>
         </p:txBody>
       </p:sp>
@@ -9993,7 +10436,7 @@
             <a:avLst/>
           </a:prstGeom>
           <a:solidFill>
-            <a:srgbClr val="0B1220"/>
+            <a:srgbClr val="F8F5F2"/>
           </a:solidFill>
           <a:ln>
             <a:noFill/>
@@ -10019,7 +10462,7 @@
           <a:lstStyle/>
           <a:p>
             <a:pPr algn="ctr"/>
-            <a:endParaRPr/>
+            <a:endParaRPr dirty="0"/>
           </a:p>
         </p:txBody>
       </p:sp>
@@ -10031,8 +10474,8 @@
         </p:nvSpPr>
         <p:spPr>
           <a:xfrm>
-            <a:off x="-386499" y="653683"/>
-            <a:ext cx="3686118" cy="169277"/>
+            <a:off x="640080" y="548640"/>
+            <a:ext cx="5486400" cy="365760"/>
           </a:xfrm>
           <a:prstGeom prst="rect">
             <a:avLst/>
@@ -10045,7 +10488,7 @@
           </a:bodyPr>
           <a:lstStyle/>
           <a:p>
-            <a:pPr algn="ctr"/>
+            <a:pPr algn="l"/>
             <a:r>
               <a:rPr sz="1100" b="1" dirty="0">
                 <a:solidFill>
@@ -10053,32 +10496,67 @@
                 </a:solidFill>
                 <a:latin typeface="Calibri"/>
               </a:rPr>
-              <a:t>08  /  TAKEAWAYS</a:t>
-            </a:r>
-          </a:p>
-        </p:txBody>
-      </p:sp>
-      <p:sp>
-        <p:nvSpPr>
-          <p:cNvPr id="4" name="Rounded Rectangle 3"/>
+              <a:t>07  /  ROADMAP</a:t>
+            </a:r>
+          </a:p>
+        </p:txBody>
+      </p:sp>
+      <p:sp>
+        <p:nvSpPr>
+          <p:cNvPr id="4" name="TextBox 3"/>
+          <p:cNvSpPr txBox="1"/>
+          <p:nvPr/>
+        </p:nvSpPr>
+        <p:spPr>
+          <a:xfrm>
+            <a:off x="640080" y="914400"/>
+            <a:ext cx="10058400" cy="914400"/>
+          </a:xfrm>
+          <a:prstGeom prst="rect">
+            <a:avLst/>
+          </a:prstGeom>
+          <a:noFill/>
+        </p:spPr>
+        <p:txBody>
+          <a:bodyPr wrap="square" lIns="0" tIns="0" rIns="0" bIns="0" anchor="t">
+            <a:spAutoFit/>
+          </a:bodyPr>
+          <a:lstStyle/>
+          <a:p>
+            <a:pPr algn="l"/>
+            <a:r>
+              <a:rPr sz="5400" b="1" dirty="0">
+                <a:solidFill>
+                  <a:srgbClr val="0F172A"/>
+                </a:solidFill>
+                <a:latin typeface="Calibri"/>
+              </a:rPr>
+              <a:t>Future steps</a:t>
+            </a:r>
+          </a:p>
+        </p:txBody>
+      </p:sp>
+      <p:sp>
+        <p:nvSpPr>
+          <p:cNvPr id="5" name="Rounded Rectangle 4"/>
           <p:cNvSpPr/>
           <p:nvPr/>
         </p:nvSpPr>
         <p:spPr>
           <a:xfrm>
-            <a:off x="3169767" y="822960"/>
-            <a:ext cx="5852160" cy="1371600"/>
+            <a:off x="640080" y="2468880"/>
+            <a:ext cx="10972800" cy="914400"/>
           </a:xfrm>
           <a:prstGeom prst="roundRect">
             <a:avLst>
-              <a:gd name="adj" fmla="val 5000"/>
+              <a:gd name="adj" fmla="val 6000"/>
             </a:avLst>
           </a:prstGeom>
-          <a:noFill/>
-          <a:ln w="28575">
-            <a:solidFill>
-              <a:srgbClr val="E11D48"/>
-            </a:solidFill>
+          <a:solidFill>
+            <a:srgbClr val="FFFFFF"/>
+          </a:solidFill>
+          <a:ln>
+            <a:noFill/>
           </a:ln>
           <a:effectLst/>
         </p:spPr>
@@ -10101,20 +10579,20 @@
           <a:lstStyle/>
           <a:p>
             <a:pPr algn="ctr"/>
-            <a:endParaRPr/>
-          </a:p>
-        </p:txBody>
-      </p:sp>
-      <p:sp>
-        <p:nvSpPr>
-          <p:cNvPr id="5" name="TextBox 4"/>
+            <a:endParaRPr dirty="0"/>
+          </a:p>
+        </p:txBody>
+      </p:sp>
+      <p:sp>
+        <p:nvSpPr>
+          <p:cNvPr id="6" name="TextBox 5"/>
           <p:cNvSpPr txBox="1"/>
           <p:nvPr/>
         </p:nvSpPr>
         <p:spPr>
           <a:xfrm>
-            <a:off x="3169767" y="822960"/>
-            <a:ext cx="5852160" cy="1371600"/>
+            <a:off x="822960" y="2560320"/>
+            <a:ext cx="914400" cy="731520"/>
           </a:xfrm>
           <a:prstGeom prst="rect">
             <a:avLst/>
@@ -10127,41 +10605,191 @@
           </a:bodyPr>
           <a:lstStyle/>
           <a:p>
-            <a:pPr algn="ctr"/>
-            <a:r>
-              <a:rPr sz="3600" b="1">
-                <a:solidFill>
-                  <a:srgbClr val="F8F5F2"/>
-                </a:solidFill>
-                <a:latin typeface="Calibri"/>
-              </a:rPr>
-              <a:t>What I've</a:t>
-            </a:r>
-          </a:p>
-          <a:p>
-            <a:pPr algn="ctr"/>
-            <a:r>
-              <a:rPr sz="3600" b="1">
-                <a:solidFill>
-                  <a:srgbClr val="F8F5F2"/>
-                </a:solidFill>
-                <a:latin typeface="Calibri"/>
-              </a:rPr>
-              <a:t>learned</a:t>
-            </a:r>
-          </a:p>
-        </p:txBody>
-      </p:sp>
-      <p:sp>
-        <p:nvSpPr>
-          <p:cNvPr id="6" name="TextBox 5"/>
+            <a:pPr algn="l"/>
+            <a:r>
+              <a:rPr sz="3200" b="1" dirty="0">
+                <a:solidFill>
+                  <a:srgbClr val="E11D48"/>
+                </a:solidFill>
+                <a:latin typeface="Calibri"/>
+              </a:rPr>
+              <a:t>01</a:t>
+            </a:r>
+          </a:p>
+        </p:txBody>
+      </p:sp>
+      <p:sp>
+        <p:nvSpPr>
+          <p:cNvPr id="7" name="Rectangle 6"/>
+          <p:cNvSpPr/>
+          <p:nvPr/>
+        </p:nvSpPr>
+        <p:spPr>
+          <a:xfrm>
+            <a:off x="1737360" y="2651760"/>
+            <a:ext cx="18288" cy="548640"/>
+          </a:xfrm>
+          <a:prstGeom prst="rect">
+            <a:avLst/>
+          </a:prstGeom>
+          <a:solidFill>
+            <a:srgbClr val="E8E2DD"/>
+          </a:solidFill>
+          <a:ln>
+            <a:noFill/>
+          </a:ln>
+          <a:effectLst/>
+        </p:spPr>
+        <p:style>
+          <a:lnRef idx="1">
+            <a:schemeClr val="accent1"/>
+          </a:lnRef>
+          <a:fillRef idx="3">
+            <a:schemeClr val="accent1"/>
+          </a:fillRef>
+          <a:effectRef idx="2">
+            <a:schemeClr val="accent1"/>
+          </a:effectRef>
+          <a:fontRef idx="minor">
+            <a:schemeClr val="lt1"/>
+          </a:fontRef>
+        </p:style>
+        <p:txBody>
+          <a:bodyPr rtlCol="0" anchor="ctr"/>
+          <a:lstStyle/>
+          <a:p>
+            <a:pPr algn="ctr"/>
+            <a:endParaRPr dirty="0"/>
+          </a:p>
+        </p:txBody>
+      </p:sp>
+      <p:sp>
+        <p:nvSpPr>
+          <p:cNvPr id="8" name="TextBox 7"/>
           <p:cNvSpPr txBox="1"/>
           <p:nvPr/>
         </p:nvSpPr>
         <p:spPr>
           <a:xfrm>
-            <a:off x="1371600" y="2423160"/>
-            <a:ext cx="640080" cy="868680"/>
+            <a:off x="1965960" y="2633472"/>
+            <a:ext cx="9144000" cy="365760"/>
+          </a:xfrm>
+          <a:prstGeom prst="rect">
+            <a:avLst/>
+          </a:prstGeom>
+          <a:noFill/>
+        </p:spPr>
+        <p:txBody>
+          <a:bodyPr wrap="square" lIns="0" tIns="0" rIns="0" bIns="0" anchor="t">
+            <a:spAutoFit/>
+          </a:bodyPr>
+          <a:lstStyle/>
+          <a:p>
+            <a:pPr algn="l"/>
+            <a:r>
+              <a:rPr sz="1800" b="1" dirty="0">
+                <a:solidFill>
+                  <a:srgbClr val="0F172A"/>
+                </a:solidFill>
+                <a:latin typeface="Calibri"/>
+              </a:rPr>
+              <a:t>Payments &amp; deposits</a:t>
+            </a:r>
+          </a:p>
+        </p:txBody>
+      </p:sp>
+      <p:sp>
+        <p:nvSpPr>
+          <p:cNvPr id="9" name="TextBox 8"/>
+          <p:cNvSpPr txBox="1"/>
+          <p:nvPr/>
+        </p:nvSpPr>
+        <p:spPr>
+          <a:xfrm>
+            <a:off x="1965960" y="2971800"/>
+            <a:ext cx="9144000" cy="365760"/>
+          </a:xfrm>
+          <a:prstGeom prst="rect">
+            <a:avLst/>
+          </a:prstGeom>
+          <a:noFill/>
+        </p:spPr>
+        <p:txBody>
+          <a:bodyPr wrap="square" lIns="0" tIns="0" rIns="0" bIns="0" anchor="t">
+            <a:spAutoFit/>
+          </a:bodyPr>
+          <a:lstStyle/>
+          <a:p>
+            <a:pPr algn="l"/>
+            <a:r>
+              <a:rPr sz="1200" b="0" dirty="0">
+                <a:solidFill>
+                  <a:srgbClr val="64748B"/>
+                </a:solidFill>
+                <a:latin typeface="Calibri"/>
+              </a:rPr>
+              <a:t>Stripe-powered booking deposits with refundable holds and owner payouts.</a:t>
+            </a:r>
+          </a:p>
+        </p:txBody>
+      </p:sp>
+      <p:sp>
+        <p:nvSpPr>
+          <p:cNvPr id="10" name="Rounded Rectangle 9"/>
+          <p:cNvSpPr/>
+          <p:nvPr/>
+        </p:nvSpPr>
+        <p:spPr>
+          <a:xfrm>
+            <a:off x="640080" y="3474720"/>
+            <a:ext cx="10972800" cy="914400"/>
+          </a:xfrm>
+          <a:prstGeom prst="roundRect">
+            <a:avLst>
+              <a:gd name="adj" fmla="val 6000"/>
+            </a:avLst>
+          </a:prstGeom>
+          <a:solidFill>
+            <a:srgbClr val="FFFFFF"/>
+          </a:solidFill>
+          <a:ln>
+            <a:noFill/>
+          </a:ln>
+          <a:effectLst/>
+        </p:spPr>
+        <p:style>
+          <a:lnRef idx="1">
+            <a:schemeClr val="accent1"/>
+          </a:lnRef>
+          <a:fillRef idx="3">
+            <a:schemeClr val="accent1"/>
+          </a:fillRef>
+          <a:effectRef idx="2">
+            <a:schemeClr val="accent1"/>
+          </a:effectRef>
+          <a:fontRef idx="minor">
+            <a:schemeClr val="lt1"/>
+          </a:fontRef>
+        </p:style>
+        <p:txBody>
+          <a:bodyPr rtlCol="0" anchor="ctr"/>
+          <a:lstStyle/>
+          <a:p>
+            <a:pPr algn="ctr"/>
+            <a:endParaRPr dirty="0"/>
+          </a:p>
+        </p:txBody>
+      </p:sp>
+      <p:sp>
+        <p:nvSpPr>
+          <p:cNvPr id="11" name="TextBox 10"/>
+          <p:cNvSpPr txBox="1"/>
+          <p:nvPr/>
+        </p:nvSpPr>
+        <p:spPr>
+          <a:xfrm>
+            <a:off x="822960" y="3566160"/>
+            <a:ext cx="914400" cy="731520"/>
           </a:xfrm>
           <a:prstGeom prst="rect">
             <a:avLst/>
@@ -10174,29 +10802,204 @@
           </a:bodyPr>
           <a:lstStyle/>
           <a:p>
-            <a:pPr algn="ctr"/>
-            <a:r>
-              <a:rPr sz="3200" b="1">
+            <a:pPr algn="l"/>
+            <a:r>
+              <a:rPr sz="3200" b="1" dirty="0">
                 <a:solidFill>
                   <a:srgbClr val="E11D48"/>
                 </a:solidFill>
                 <a:latin typeface="Calibri"/>
               </a:rPr>
-              <a:t>1</a:t>
-            </a:r>
-          </a:p>
-        </p:txBody>
-      </p:sp>
-      <p:sp>
-        <p:nvSpPr>
-          <p:cNvPr id="7" name="TextBox 6"/>
+              <a:t>02</a:t>
+            </a:r>
+          </a:p>
+        </p:txBody>
+      </p:sp>
+      <p:sp>
+        <p:nvSpPr>
+          <p:cNvPr id="12" name="Rectangle 11"/>
+          <p:cNvSpPr/>
+          <p:nvPr/>
+        </p:nvSpPr>
+        <p:spPr>
+          <a:xfrm>
+            <a:off x="1737360" y="3657600"/>
+            <a:ext cx="18288" cy="548640"/>
+          </a:xfrm>
+          <a:prstGeom prst="rect">
+            <a:avLst/>
+          </a:prstGeom>
+          <a:solidFill>
+            <a:srgbClr val="E8E2DD"/>
+          </a:solidFill>
+          <a:ln>
+            <a:noFill/>
+          </a:ln>
+          <a:effectLst/>
+        </p:spPr>
+        <p:style>
+          <a:lnRef idx="1">
+            <a:schemeClr val="accent1"/>
+          </a:lnRef>
+          <a:fillRef idx="3">
+            <a:schemeClr val="accent1"/>
+          </a:fillRef>
+          <a:effectRef idx="2">
+            <a:schemeClr val="accent1"/>
+          </a:effectRef>
+          <a:fontRef idx="minor">
+            <a:schemeClr val="lt1"/>
+          </a:fontRef>
+        </p:style>
+        <p:txBody>
+          <a:bodyPr rtlCol="0" anchor="ctr"/>
+          <a:lstStyle/>
+          <a:p>
+            <a:pPr algn="ctr"/>
+            <a:endParaRPr dirty="0"/>
+          </a:p>
+        </p:txBody>
+      </p:sp>
+      <p:sp>
+        <p:nvSpPr>
+          <p:cNvPr id="13" name="TextBox 12"/>
           <p:cNvSpPr txBox="1"/>
           <p:nvPr/>
         </p:nvSpPr>
         <p:spPr>
           <a:xfrm>
-            <a:off x="2194560" y="2423160"/>
-            <a:ext cx="9052560" cy="868680"/>
+            <a:off x="1965960" y="3639312"/>
+            <a:ext cx="9144000" cy="276999"/>
+          </a:xfrm>
+          <a:prstGeom prst="rect">
+            <a:avLst/>
+          </a:prstGeom>
+          <a:noFill/>
+        </p:spPr>
+        <p:txBody>
+          <a:bodyPr wrap="square" lIns="0" tIns="0" rIns="0" bIns="0" anchor="t">
+            <a:spAutoFit/>
+          </a:bodyPr>
+          <a:lstStyle/>
+          <a:p>
+            <a:r>
+              <a:rPr lang="en-US" b="1" dirty="0">
+                <a:solidFill>
+                  <a:srgbClr val="0F172A"/>
+                </a:solidFill>
+                <a:latin typeface="Calibri"/>
+              </a:rPr>
+              <a:t>Reviews &amp; ratings</a:t>
+            </a:r>
+            <a:endParaRPr b="1" dirty="0">
+              <a:solidFill>
+                <a:srgbClr val="0F172A"/>
+              </a:solidFill>
+              <a:latin typeface="Calibri"/>
+            </a:endParaRPr>
+          </a:p>
+        </p:txBody>
+      </p:sp>
+      <p:sp>
+        <p:nvSpPr>
+          <p:cNvPr id="14" name="TextBox 13"/>
+          <p:cNvSpPr txBox="1"/>
+          <p:nvPr/>
+        </p:nvSpPr>
+        <p:spPr>
+          <a:xfrm>
+            <a:off x="1965960" y="3977640"/>
+            <a:ext cx="9144000" cy="184666"/>
+          </a:xfrm>
+          <a:prstGeom prst="rect">
+            <a:avLst/>
+          </a:prstGeom>
+          <a:noFill/>
+        </p:spPr>
+        <p:txBody>
+          <a:bodyPr wrap="square" lIns="0" tIns="0" rIns="0" bIns="0" anchor="t">
+            <a:spAutoFit/>
+          </a:bodyPr>
+          <a:lstStyle/>
+          <a:p>
+            <a:r>
+              <a:rPr lang="en-US" sz="1200" dirty="0">
+                <a:solidFill>
+                  <a:srgbClr val="64748B"/>
+                </a:solidFill>
+                <a:latin typeface="Calibri"/>
+              </a:rPr>
+              <a:t>Let renters leave reviews for listings and owners after a viewing or stay</a:t>
+            </a:r>
+            <a:r>
+              <a:rPr sz="1200" dirty="0">
+                <a:solidFill>
+                  <a:srgbClr val="64748B"/>
+                </a:solidFill>
+                <a:latin typeface="Calibri"/>
+              </a:rPr>
+              <a:t>.</a:t>
+            </a:r>
+          </a:p>
+        </p:txBody>
+      </p:sp>
+      <p:sp>
+        <p:nvSpPr>
+          <p:cNvPr id="15" name="Rounded Rectangle 14"/>
+          <p:cNvSpPr/>
+          <p:nvPr/>
+        </p:nvSpPr>
+        <p:spPr>
+          <a:xfrm>
+            <a:off x="640080" y="4480560"/>
+            <a:ext cx="10972800" cy="914400"/>
+          </a:xfrm>
+          <a:prstGeom prst="roundRect">
+            <a:avLst>
+              <a:gd name="adj" fmla="val 6000"/>
+            </a:avLst>
+          </a:prstGeom>
+          <a:solidFill>
+            <a:srgbClr val="FFFFFF"/>
+          </a:solidFill>
+          <a:ln>
+            <a:noFill/>
+          </a:ln>
+          <a:effectLst/>
+        </p:spPr>
+        <p:style>
+          <a:lnRef idx="1">
+            <a:schemeClr val="accent1"/>
+          </a:lnRef>
+          <a:fillRef idx="3">
+            <a:schemeClr val="accent1"/>
+          </a:fillRef>
+          <a:effectRef idx="2">
+            <a:schemeClr val="accent1"/>
+          </a:effectRef>
+          <a:fontRef idx="minor">
+            <a:schemeClr val="lt1"/>
+          </a:fontRef>
+        </p:style>
+        <p:txBody>
+          <a:bodyPr rtlCol="0" anchor="ctr"/>
+          <a:lstStyle/>
+          <a:p>
+            <a:pPr algn="ctr"/>
+            <a:endParaRPr dirty="0"/>
+          </a:p>
+        </p:txBody>
+      </p:sp>
+      <p:sp>
+        <p:nvSpPr>
+          <p:cNvPr id="16" name="TextBox 15"/>
+          <p:cNvSpPr txBox="1"/>
+          <p:nvPr/>
+        </p:nvSpPr>
+        <p:spPr>
+          <a:xfrm>
+            <a:off x="822960" y="4572000"/>
+            <a:ext cx="914400" cy="731520"/>
           </a:xfrm>
           <a:prstGeom prst="rect">
             <a:avLst/>
@@ -10211,27 +11014,72 @@
           <a:p>
             <a:pPr algn="l"/>
             <a:r>
-              <a:rPr sz="1500" b="1">
-                <a:solidFill>
-                  <a:srgbClr val="F8F5F2"/>
-                </a:solidFill>
-                <a:latin typeface="Calibri"/>
-              </a:rPr>
-              <a:t>BUILD A FULL-STACK PRODUCT FROM SCRATCH — BACKEND, FRONTEND AND CLOUD</a:t>
-            </a:r>
-          </a:p>
-        </p:txBody>
-      </p:sp>
-      <p:sp>
-        <p:nvSpPr>
-          <p:cNvPr id="8" name="TextBox 7"/>
+              <a:rPr sz="3200" b="1" dirty="0">
+                <a:solidFill>
+                  <a:srgbClr val="E11D48"/>
+                </a:solidFill>
+                <a:latin typeface="Calibri"/>
+              </a:rPr>
+              <a:t>03</a:t>
+            </a:r>
+          </a:p>
+        </p:txBody>
+      </p:sp>
+      <p:sp>
+        <p:nvSpPr>
+          <p:cNvPr id="17" name="Rectangle 16"/>
+          <p:cNvSpPr/>
+          <p:nvPr/>
+        </p:nvSpPr>
+        <p:spPr>
+          <a:xfrm>
+            <a:off x="1737360" y="4663440"/>
+            <a:ext cx="18288" cy="548640"/>
+          </a:xfrm>
+          <a:prstGeom prst="rect">
+            <a:avLst/>
+          </a:prstGeom>
+          <a:solidFill>
+            <a:srgbClr val="E8E2DD"/>
+          </a:solidFill>
+          <a:ln>
+            <a:noFill/>
+          </a:ln>
+          <a:effectLst/>
+        </p:spPr>
+        <p:style>
+          <a:lnRef idx="1">
+            <a:schemeClr val="accent1"/>
+          </a:lnRef>
+          <a:fillRef idx="3">
+            <a:schemeClr val="accent1"/>
+          </a:fillRef>
+          <a:effectRef idx="2">
+            <a:schemeClr val="accent1"/>
+          </a:effectRef>
+          <a:fontRef idx="minor">
+            <a:schemeClr val="lt1"/>
+          </a:fontRef>
+        </p:style>
+        <p:txBody>
+          <a:bodyPr rtlCol="0" anchor="ctr"/>
+          <a:lstStyle/>
+          <a:p>
+            <a:pPr algn="ctr"/>
+            <a:endParaRPr dirty="0"/>
+          </a:p>
+        </p:txBody>
+      </p:sp>
+      <p:sp>
+        <p:nvSpPr>
+          <p:cNvPr id="18" name="TextBox 17"/>
           <p:cNvSpPr txBox="1"/>
           <p:nvPr/>
         </p:nvSpPr>
         <p:spPr>
           <a:xfrm>
-            <a:off x="1371600" y="3291840"/>
-            <a:ext cx="640080" cy="868680"/>
+            <a:off x="1965960" y="4645152"/>
+            <a:ext cx="9144000" cy="276999"/>
           </a:xfrm>
           <a:prstGeom prst="rect">
             <a:avLst/>
@@ -10239,34 +11087,39 @@
           <a:noFill/>
         </p:spPr>
         <p:txBody>
-          <a:bodyPr wrap="square" lIns="0" tIns="0" rIns="0" bIns="0" anchor="ctr">
+          <a:bodyPr wrap="square" lIns="0" tIns="0" rIns="0" bIns="0" anchor="t">
             <a:spAutoFit/>
           </a:bodyPr>
           <a:lstStyle/>
           <a:p>
-            <a:pPr algn="ctr"/>
-            <a:r>
-              <a:rPr sz="3200" b="1">
-                <a:solidFill>
-                  <a:srgbClr val="E11D48"/>
-                </a:solidFill>
-                <a:latin typeface="Calibri"/>
-              </a:rPr>
-              <a:t>2</a:t>
-            </a:r>
-          </a:p>
-        </p:txBody>
-      </p:sp>
-      <p:sp>
-        <p:nvSpPr>
-          <p:cNvPr id="9" name="TextBox 8"/>
+            <a:r>
+              <a:rPr lang="en-US" b="1" dirty="0">
+                <a:solidFill>
+                  <a:srgbClr val="0F172A"/>
+                </a:solidFill>
+                <a:latin typeface="Calibri"/>
+              </a:rPr>
+              <a:t>Saved search alerts</a:t>
+            </a:r>
+            <a:endParaRPr b="1" dirty="0">
+              <a:solidFill>
+                <a:srgbClr val="0F172A"/>
+              </a:solidFill>
+              <a:latin typeface="Calibri"/>
+            </a:endParaRPr>
+          </a:p>
+        </p:txBody>
+      </p:sp>
+      <p:sp>
+        <p:nvSpPr>
+          <p:cNvPr id="19" name="TextBox 18"/>
           <p:cNvSpPr txBox="1"/>
           <p:nvPr/>
         </p:nvSpPr>
         <p:spPr>
           <a:xfrm>
-            <a:off x="2194560" y="3291840"/>
-            <a:ext cx="9052560" cy="868680"/>
+            <a:off x="1965960" y="4983480"/>
+            <a:ext cx="9144000" cy="184666"/>
           </a:xfrm>
           <a:prstGeom prst="rect">
             <a:avLst/>
@@ -10274,231 +11127,26 @@
           <a:noFill/>
         </p:spPr>
         <p:txBody>
-          <a:bodyPr wrap="square" lIns="0" tIns="0" rIns="0" bIns="0" anchor="ctr">
+          <a:bodyPr wrap="square" lIns="0" tIns="0" rIns="0" bIns="0" anchor="t">
             <a:spAutoFit/>
           </a:bodyPr>
           <a:lstStyle/>
           <a:p>
-            <a:pPr algn="l"/>
-            <a:r>
-              <a:rPr sz="1500" b="1">
-                <a:solidFill>
-                  <a:srgbClr val="F8F5F2"/>
-                </a:solidFill>
-                <a:latin typeface="Calibri"/>
-              </a:rPr>
-              <a:t>WRITE CLEAN, WELL-STRUCTURED CODE THAT IS EASY TO EXTEND AND MAINTAIN</a:t>
-            </a:r>
-          </a:p>
-        </p:txBody>
-      </p:sp>
-      <p:sp>
-        <p:nvSpPr>
-          <p:cNvPr id="10" name="TextBox 9"/>
-          <p:cNvSpPr txBox="1"/>
-          <p:nvPr/>
-        </p:nvSpPr>
-        <p:spPr>
-          <a:xfrm>
-            <a:off x="1371600" y="4160520"/>
-            <a:ext cx="640080" cy="868680"/>
-          </a:xfrm>
-          <a:prstGeom prst="rect">
-            <a:avLst/>
-          </a:prstGeom>
-          <a:noFill/>
-        </p:spPr>
-        <p:txBody>
-          <a:bodyPr wrap="square" lIns="0" tIns="0" rIns="0" bIns="0" anchor="ctr">
-            <a:spAutoFit/>
-          </a:bodyPr>
-          <a:lstStyle/>
-          <a:p>
-            <a:pPr algn="ctr"/>
-            <a:r>
-              <a:rPr sz="3200" b="1">
-                <a:solidFill>
-                  <a:srgbClr val="E11D48"/>
-                </a:solidFill>
-                <a:latin typeface="Calibri"/>
-              </a:rPr>
-              <a:t>3</a:t>
-            </a:r>
-          </a:p>
-        </p:txBody>
-      </p:sp>
-      <p:sp>
-        <p:nvSpPr>
-          <p:cNvPr id="11" name="TextBox 10"/>
-          <p:cNvSpPr txBox="1"/>
-          <p:nvPr/>
-        </p:nvSpPr>
-        <p:spPr>
-          <a:xfrm>
-            <a:off x="2194560" y="4160520"/>
-            <a:ext cx="9052560" cy="868680"/>
-          </a:xfrm>
-          <a:prstGeom prst="rect">
-            <a:avLst/>
-          </a:prstGeom>
-          <a:noFill/>
-        </p:spPr>
-        <p:txBody>
-          <a:bodyPr wrap="square" lIns="0" tIns="0" rIns="0" bIns="0" anchor="ctr">
-            <a:spAutoFit/>
-          </a:bodyPr>
-          <a:lstStyle/>
-          <a:p>
-            <a:pPr algn="l"/>
-            <a:r>
-              <a:rPr sz="1500" b="1">
-                <a:solidFill>
-                  <a:srgbClr val="F8F5F2"/>
-                </a:solidFill>
-                <a:latin typeface="Calibri"/>
-              </a:rPr>
-              <a:t>DESIGN A RESPONSIVE INTERFACE THAT WORKS BEAUTIFULLY ON ANY DEVICE</a:t>
-            </a:r>
-          </a:p>
-        </p:txBody>
-      </p:sp>
-      <p:sp>
-        <p:nvSpPr>
-          <p:cNvPr id="12" name="TextBox 11"/>
-          <p:cNvSpPr txBox="1"/>
-          <p:nvPr/>
-        </p:nvSpPr>
-        <p:spPr>
-          <a:xfrm>
-            <a:off x="1371600" y="5029200"/>
-            <a:ext cx="640080" cy="868680"/>
-          </a:xfrm>
-          <a:prstGeom prst="rect">
-            <a:avLst/>
-          </a:prstGeom>
-          <a:noFill/>
-        </p:spPr>
-        <p:txBody>
-          <a:bodyPr wrap="square" lIns="0" tIns="0" rIns="0" bIns="0" anchor="ctr">
-            <a:spAutoFit/>
-          </a:bodyPr>
-          <a:lstStyle/>
-          <a:p>
-            <a:pPr algn="ctr"/>
-            <a:r>
-              <a:rPr sz="3200" b="1">
-                <a:solidFill>
-                  <a:srgbClr val="E11D48"/>
-                </a:solidFill>
-                <a:latin typeface="Calibri"/>
-              </a:rPr>
-              <a:t>4</a:t>
-            </a:r>
-          </a:p>
-        </p:txBody>
-      </p:sp>
-      <p:sp>
-        <p:nvSpPr>
-          <p:cNvPr id="13" name="TextBox 12"/>
-          <p:cNvSpPr txBox="1"/>
-          <p:nvPr/>
-        </p:nvSpPr>
-        <p:spPr>
-          <a:xfrm>
-            <a:off x="2194560" y="5029200"/>
-            <a:ext cx="9052560" cy="868680"/>
-          </a:xfrm>
-          <a:prstGeom prst="rect">
-            <a:avLst/>
-          </a:prstGeom>
-          <a:noFill/>
-        </p:spPr>
-        <p:txBody>
-          <a:bodyPr wrap="square" lIns="0" tIns="0" rIns="0" bIns="0" anchor="ctr">
-            <a:spAutoFit/>
-          </a:bodyPr>
-          <a:lstStyle/>
-          <a:p>
-            <a:pPr algn="l"/>
-            <a:r>
-              <a:rPr sz="1500" b="1">
-                <a:solidFill>
-                  <a:srgbClr val="F8F5F2"/>
-                </a:solidFill>
-                <a:latin typeface="Calibri"/>
-              </a:rPr>
-              <a:t>DEPLOY AND RUN A REAL APPLICATION IN A PRODUCTION ENVIRONMENT</a:t>
-            </a:r>
-          </a:p>
-        </p:txBody>
-      </p:sp>
-      <p:sp>
-        <p:nvSpPr>
-          <p:cNvPr id="14" name="TextBox 13"/>
-          <p:cNvSpPr txBox="1"/>
-          <p:nvPr/>
-        </p:nvSpPr>
-        <p:spPr>
-          <a:xfrm>
-            <a:off x="1371600" y="5897880"/>
-            <a:ext cx="640080" cy="868680"/>
-          </a:xfrm>
-          <a:prstGeom prst="rect">
-            <a:avLst/>
-          </a:prstGeom>
-          <a:noFill/>
-        </p:spPr>
-        <p:txBody>
-          <a:bodyPr wrap="square" lIns="0" tIns="0" rIns="0" bIns="0" anchor="ctr">
-            <a:spAutoFit/>
-          </a:bodyPr>
-          <a:lstStyle/>
-          <a:p>
-            <a:pPr algn="ctr"/>
-            <a:r>
-              <a:rPr sz="3200" b="1">
-                <a:solidFill>
-                  <a:srgbClr val="E11D48"/>
-                </a:solidFill>
-                <a:latin typeface="Calibri"/>
-              </a:rPr>
-              <a:t>5</a:t>
-            </a:r>
-          </a:p>
-        </p:txBody>
-      </p:sp>
-      <p:sp>
-        <p:nvSpPr>
-          <p:cNvPr id="15" name="TextBox 14"/>
-          <p:cNvSpPr txBox="1"/>
-          <p:nvPr/>
-        </p:nvSpPr>
-        <p:spPr>
-          <a:xfrm>
-            <a:off x="2194560" y="5897880"/>
-            <a:ext cx="9052560" cy="868680"/>
-          </a:xfrm>
-          <a:prstGeom prst="rect">
-            <a:avLst/>
-          </a:prstGeom>
-          <a:noFill/>
-        </p:spPr>
-        <p:txBody>
-          <a:bodyPr wrap="square" lIns="0" tIns="0" rIns="0" bIns="0" anchor="ctr">
-            <a:spAutoFit/>
-          </a:bodyPr>
-          <a:lstStyle/>
-          <a:p>
-            <a:pPr algn="l"/>
-            <a:r>
-              <a:rPr sz="1500" b="1">
-                <a:solidFill>
-                  <a:srgbClr val="F8F5F2"/>
-                </a:solidFill>
-                <a:latin typeface="Calibri"/>
-              </a:rPr>
-              <a:t>SOLVE REAL PROBLEMS AND GROW AS A DEVELOPER WITH EVERY COMMIT</a:t>
-            </a:r>
+            <a:r>
+              <a:rPr lang="en-US" sz="1200" dirty="0">
+                <a:solidFill>
+                  <a:srgbClr val="64748B"/>
+                </a:solidFill>
+                <a:latin typeface="Calibri"/>
+              </a:rPr>
+              <a:t>Notify users when a new listing matches their saved search criteria.</a:t>
+            </a:r>
+            <a:endParaRPr sz="1200" dirty="0">
+              <a:solidFill>
+                <a:srgbClr val="64748B"/>
+              </a:solidFill>
+              <a:latin typeface="Calibri"/>
+            </a:endParaRPr>
           </a:p>
         </p:txBody>
       </p:sp>

</xml_diff>